<commit_message>
MAMS-10 update meeting note
</commit_message>
<xml_diff>
--- a/docs/meetings/weekly-meeting_29-03-2026.pptx
+++ b/docs/meetings/weekly-meeting_29-03-2026.pptx
@@ -137,7 +137,7 @@
 <file path=ppt/revisionInfo.xml><?xml version="1.0" encoding="utf-8"?>
 <p1510:revInfo xmlns:a="http://schemas.openxmlformats.org/drawingml/2006/main" xmlns:r="http://schemas.openxmlformats.org/officeDocument/2006/relationships" xmlns:p1510="http://schemas.microsoft.com/office/powerpoint/2015/10/main">
   <p1510:revLst>
-    <p1510:client id="{7D8275EE-B700-D7F4-297E-EB361C7BC9BE}" v="65" dt="2026-01-30T08:09:57.139"/>
+    <p1510:client id="{7A19EAD3-05A1-428F-9BD4-D8E46B39D91C}" v="2" dt="2026-03-28T04:06:09.257"/>
   </p1510:revLst>
 </p1510:revInfo>
 </file>
@@ -147,664 +147,478 @@
   <pc:docChgLst>
     <pc:chgData name="Minh Khôi Võ Tấn" userId="df010977c1c328cb" providerId="LiveId" clId="{021737E1-13EE-495B-A898-B29314BB33F8}"/>
     <pc:docChg chg="undo redo custSel addSld delSld modSld modSection">
-      <pc:chgData name="Minh Khôi Võ Tấn" userId="df010977c1c328cb" providerId="LiveId" clId="{021737E1-13EE-495B-A898-B29314BB33F8}" dt="2026-01-18T13:05:50.700" v="3178" actId="1582"/>
+      <pc:chgData name="Minh Khôi Võ Tấn" userId="df010977c1c328cb" providerId="LiveId" clId="{021737E1-13EE-495B-A898-B29314BB33F8}" dt="2026-03-28T04:13:53.942" v="3208" actId="1076"/>
       <pc:docMkLst>
         <pc:docMk/>
       </pc:docMkLst>
-      <pc:sldChg chg="modSp mod">
-        <pc:chgData name="Minh Khôi Võ Tấn" userId="df010977c1c328cb" providerId="LiveId" clId="{021737E1-13EE-495B-A898-B29314BB33F8}" dt="2026-01-08T17:37:56.394" v="2887" actId="20577"/>
+      <pc:sldChg chg="addSp delSp modSp mod">
+        <pc:chgData name="Minh Khôi Võ Tấn" userId="df010977c1c328cb" providerId="LiveId" clId="{021737E1-13EE-495B-A898-B29314BB33F8}" dt="2026-03-28T04:13:53.942" v="3208" actId="1076"/>
         <pc:sldMkLst>
           <pc:docMk/>
-          <pc:sldMk cId="3944462662" sldId="256"/>
+          <pc:sldMk cId="3653425752" sldId="258"/>
         </pc:sldMkLst>
-        <pc:spChg chg="mod">
-          <ac:chgData name="Minh Khôi Võ Tấn" userId="df010977c1c328cb" providerId="LiveId" clId="{021737E1-13EE-495B-A898-B29314BB33F8}" dt="2026-01-08T17:37:56.394" v="2887" actId="20577"/>
-          <ac:spMkLst>
+        <pc:grpChg chg="mod">
+          <ac:chgData name="Minh Khôi Võ Tấn" userId="df010977c1c328cb" providerId="LiveId" clId="{021737E1-13EE-495B-A898-B29314BB33F8}" dt="2026-03-28T04:06:04.394" v="3201"/>
+          <ac:grpSpMkLst>
             <pc:docMk/>
-            <pc:sldMk cId="3944462662" sldId="256"/>
-            <ac:spMk id="2" creationId="{9788C130-FAB7-3278-D1B1-D087BA9E3038}"/>
-          </ac:spMkLst>
-        </pc:spChg>
+            <pc:sldMk cId="3653425752" sldId="258"/>
+            <ac:grpSpMk id="14" creationId="{F8F33CF3-BAFC-E7A6-C5C7-2EA9469B5223}"/>
+          </ac:grpSpMkLst>
+        </pc:grpChg>
+        <pc:grpChg chg="mod">
+          <ac:chgData name="Minh Khôi Võ Tấn" userId="df010977c1c328cb" providerId="LiveId" clId="{021737E1-13EE-495B-A898-B29314BB33F8}" dt="2026-03-28T04:06:09.257" v="3206"/>
+          <ac:grpSpMkLst>
+            <pc:docMk/>
+            <pc:sldMk cId="3653425752" sldId="258"/>
+            <ac:grpSpMk id="20" creationId="{80389C47-2DF7-4E50-AC89-03E2218326CB}"/>
+          </ac:grpSpMkLst>
+        </pc:grpChg>
+        <pc:picChg chg="mod">
+          <ac:chgData name="Minh Khôi Võ Tấn" userId="df010977c1c328cb" providerId="LiveId" clId="{021737E1-13EE-495B-A898-B29314BB33F8}" dt="2026-03-28T04:13:53.942" v="3208" actId="1076"/>
+          <ac:picMkLst>
+            <pc:docMk/>
+            <pc:sldMk cId="3653425752" sldId="258"/>
+            <ac:picMk id="13" creationId="{C046EAE9-E2CF-DDFF-C359-683BFFF81276}"/>
+          </ac:picMkLst>
+        </pc:picChg>
+        <pc:picChg chg="mod">
+          <ac:chgData name="Minh Khôi Võ Tấn" userId="df010977c1c328cb" providerId="LiveId" clId="{021737E1-13EE-495B-A898-B29314BB33F8}" dt="2026-03-28T04:03:08.956" v="3189" actId="14100"/>
+          <ac:picMkLst>
+            <pc:docMk/>
+            <pc:sldMk cId="3653425752" sldId="258"/>
+            <ac:picMk id="15" creationId="{2E18EC18-1E5E-AA7B-F271-A147A86C4357}"/>
+          </ac:picMkLst>
+        </pc:picChg>
+        <pc:inkChg chg="add del">
+          <ac:chgData name="Minh Khôi Võ Tấn" userId="df010977c1c328cb" providerId="LiveId" clId="{021737E1-13EE-495B-A898-B29314BB33F8}" dt="2026-03-28T04:05:10.379" v="3192" actId="9405"/>
+          <ac:inkMkLst>
+            <pc:docMk/>
+            <pc:sldMk cId="3653425752" sldId="258"/>
+            <ac:inkMk id="3" creationId="{06E0E5CD-B6EB-8806-13B9-28D811B69332}"/>
+          </ac:inkMkLst>
+        </pc:inkChg>
+        <pc:inkChg chg="add del">
+          <ac:chgData name="Minh Khôi Võ Tấn" userId="df010977c1c328cb" providerId="LiveId" clId="{021737E1-13EE-495B-A898-B29314BB33F8}" dt="2026-03-28T04:05:17.431" v="3194" actId="9405"/>
+          <ac:inkMkLst>
+            <pc:docMk/>
+            <pc:sldMk cId="3653425752" sldId="258"/>
+            <ac:inkMk id="6" creationId="{E6681A5E-9614-EEA7-147C-6707EB454CC6}"/>
+          </ac:inkMkLst>
+        </pc:inkChg>
+        <pc:inkChg chg="add">
+          <ac:chgData name="Minh Khôi Võ Tấn" userId="df010977c1c328cb" providerId="LiveId" clId="{021737E1-13EE-495B-A898-B29314BB33F8}" dt="2026-03-28T04:05:31.399" v="3195" actId="9405"/>
+          <ac:inkMkLst>
+            <pc:docMk/>
+            <pc:sldMk cId="3653425752" sldId="258"/>
+            <ac:inkMk id="7" creationId="{DABCA7AF-6723-2C7D-9066-C596DBE2BDAC}"/>
+          </ac:inkMkLst>
+        </pc:inkChg>
+        <pc:inkChg chg="add">
+          <ac:chgData name="Minh Khôi Võ Tấn" userId="df010977c1c328cb" providerId="LiveId" clId="{021737E1-13EE-495B-A898-B29314BB33F8}" dt="2026-03-28T04:05:41.277" v="3196" actId="9405"/>
+          <ac:inkMkLst>
+            <pc:docMk/>
+            <pc:sldMk cId="3653425752" sldId="258"/>
+            <ac:inkMk id="8" creationId="{8C83603A-FE42-D96B-E79F-8754A05C4C20}"/>
+          </ac:inkMkLst>
+        </pc:inkChg>
+        <pc:inkChg chg="add mod">
+          <ac:chgData name="Minh Khôi Võ Tấn" userId="df010977c1c328cb" providerId="LiveId" clId="{021737E1-13EE-495B-A898-B29314BB33F8}" dt="2026-03-28T04:06:04.394" v="3201"/>
+          <ac:inkMkLst>
+            <pc:docMk/>
+            <pc:sldMk cId="3653425752" sldId="258"/>
+            <ac:inkMk id="9" creationId="{1BE72EBC-F190-D234-281D-AC1D1FB28F06}"/>
+          </ac:inkMkLst>
+        </pc:inkChg>
+        <pc:inkChg chg="add mod">
+          <ac:chgData name="Minh Khôi Võ Tấn" userId="df010977c1c328cb" providerId="LiveId" clId="{021737E1-13EE-495B-A898-B29314BB33F8}" dt="2026-03-28T04:06:04.394" v="3201"/>
+          <ac:inkMkLst>
+            <pc:docMk/>
+            <pc:sldMk cId="3653425752" sldId="258"/>
+            <ac:inkMk id="10" creationId="{5287171E-06E2-8CD6-8E90-55B0960D0298}"/>
+          </ac:inkMkLst>
+        </pc:inkChg>
+        <pc:inkChg chg="add mod">
+          <ac:chgData name="Minh Khôi Võ Tấn" userId="df010977c1c328cb" providerId="LiveId" clId="{021737E1-13EE-495B-A898-B29314BB33F8}" dt="2026-03-28T04:06:04.394" v="3201"/>
+          <ac:inkMkLst>
+            <pc:docMk/>
+            <pc:sldMk cId="3653425752" sldId="258"/>
+            <ac:inkMk id="11" creationId="{2054F2F8-89B7-F617-6D3B-6F29284D6F50}"/>
+          </ac:inkMkLst>
+        </pc:inkChg>
+        <pc:inkChg chg="add mod">
+          <ac:chgData name="Minh Khôi Võ Tấn" userId="df010977c1c328cb" providerId="LiveId" clId="{021737E1-13EE-495B-A898-B29314BB33F8}" dt="2026-03-28T04:06:04.394" v="3201"/>
+          <ac:inkMkLst>
+            <pc:docMk/>
+            <pc:sldMk cId="3653425752" sldId="258"/>
+            <ac:inkMk id="12" creationId="{2151B651-9AD4-E33D-93A8-EB4D457A8509}"/>
+          </ac:inkMkLst>
+        </pc:inkChg>
+        <pc:inkChg chg="add mod">
+          <ac:chgData name="Minh Khôi Võ Tấn" userId="df010977c1c328cb" providerId="LiveId" clId="{021737E1-13EE-495B-A898-B29314BB33F8}" dt="2026-03-28T04:06:09.257" v="3206"/>
+          <ac:inkMkLst>
+            <pc:docMk/>
+            <pc:sldMk cId="3653425752" sldId="258"/>
+            <ac:inkMk id="16" creationId="{A2CA2E82-2959-9DD2-9417-6F11BE5ABE62}"/>
+          </ac:inkMkLst>
+        </pc:inkChg>
+        <pc:inkChg chg="add mod">
+          <ac:chgData name="Minh Khôi Võ Tấn" userId="df010977c1c328cb" providerId="LiveId" clId="{021737E1-13EE-495B-A898-B29314BB33F8}" dt="2026-03-28T04:06:09.257" v="3206"/>
+          <ac:inkMkLst>
+            <pc:docMk/>
+            <pc:sldMk cId="3653425752" sldId="258"/>
+            <ac:inkMk id="17" creationId="{1C4F3452-3EFC-C8BB-483A-54308F4A61CB}"/>
+          </ac:inkMkLst>
+        </pc:inkChg>
+        <pc:inkChg chg="add mod">
+          <ac:chgData name="Minh Khôi Võ Tấn" userId="df010977c1c328cb" providerId="LiveId" clId="{021737E1-13EE-495B-A898-B29314BB33F8}" dt="2026-03-28T04:06:09.257" v="3206"/>
+          <ac:inkMkLst>
+            <pc:docMk/>
+            <pc:sldMk cId="3653425752" sldId="258"/>
+            <ac:inkMk id="18" creationId="{52CF8459-8CB6-B095-3F2F-BECCA85C1504}"/>
+          </ac:inkMkLst>
+        </pc:inkChg>
+        <pc:inkChg chg="add mod">
+          <ac:chgData name="Minh Khôi Võ Tấn" userId="df010977c1c328cb" providerId="LiveId" clId="{021737E1-13EE-495B-A898-B29314BB33F8}" dt="2026-03-28T04:06:09.257" v="3206"/>
+          <ac:inkMkLst>
+            <pc:docMk/>
+            <pc:sldMk cId="3653425752" sldId="258"/>
+            <ac:inkMk id="19" creationId="{4243751C-6893-88C1-33AC-148358F0C989}"/>
+          </ac:inkMkLst>
+        </pc:inkChg>
+        <pc:inkChg chg="add">
+          <ac:chgData name="Minh Khôi Võ Tấn" userId="df010977c1c328cb" providerId="LiveId" clId="{021737E1-13EE-495B-A898-B29314BB33F8}" dt="2026-03-28T04:13:50.294" v="3207" actId="9405"/>
+          <ac:inkMkLst>
+            <pc:docMk/>
+            <pc:sldMk cId="3653425752" sldId="258"/>
+            <ac:inkMk id="21" creationId="{927E7234-FB57-C1B2-7CC1-00C133A1E295}"/>
+          </ac:inkMkLst>
+        </pc:inkChg>
       </pc:sldChg>
-      <pc:sldChg chg="addSp delSp modSp mod">
-        <pc:chgData name="Minh Khôi Võ Tấn" userId="df010977c1c328cb" providerId="LiveId" clId="{021737E1-13EE-495B-A898-B29314BB33F8}" dt="2026-01-04T12:29:18.302" v="2231" actId="1076"/>
+      <pc:sldChg chg="modSp mod">
+        <pc:chgData name="Minh Khôi Võ Tấn" userId="df010977c1c328cb" providerId="LiveId" clId="{021737E1-13EE-495B-A898-B29314BB33F8}" dt="2026-03-28T03:56:06.639" v="3186" actId="14100"/>
         <pc:sldMkLst>
           <pc:docMk/>
-          <pc:sldMk cId="1597710949" sldId="258"/>
+          <pc:sldMk cId="391511365" sldId="261"/>
         </pc:sldMkLst>
-        <pc:spChg chg="mod">
-          <ac:chgData name="Minh Khôi Võ Tấn" userId="df010977c1c328cb" providerId="LiveId" clId="{021737E1-13EE-495B-A898-B29314BB33F8}" dt="2026-01-04T12:04:47.297" v="1976" actId="20577"/>
-          <ac:spMkLst>
-            <pc:docMk/>
-            <pc:sldMk cId="1597710949" sldId="258"/>
-            <ac:spMk id="2" creationId="{8CA08402-3F61-20D8-3D3C-188C78B0E2A1}"/>
-          </ac:spMkLst>
-        </pc:spChg>
-        <pc:spChg chg="add mod">
-          <ac:chgData name="Minh Khôi Võ Tấn" userId="df010977c1c328cb" providerId="LiveId" clId="{021737E1-13EE-495B-A898-B29314BB33F8}" dt="2026-01-04T12:28:42.614" v="2223" actId="1076"/>
-          <ac:spMkLst>
-            <pc:docMk/>
-            <pc:sldMk cId="1597710949" sldId="258"/>
-            <ac:spMk id="3" creationId="{3FE34BEB-B984-2E5D-5755-977D7B4A304E}"/>
-          </ac:spMkLst>
-        </pc:spChg>
-        <pc:picChg chg="add mod">
-          <ac:chgData name="Minh Khôi Võ Tấn" userId="df010977c1c328cb" providerId="LiveId" clId="{021737E1-13EE-495B-A898-B29314BB33F8}" dt="2026-01-04T12:28:56.638" v="2225" actId="1076"/>
+        <pc:picChg chg="mod">
+          <ac:chgData name="Minh Khôi Võ Tấn" userId="df010977c1c328cb" providerId="LiveId" clId="{021737E1-13EE-495B-A898-B29314BB33F8}" dt="2026-03-28T03:56:03.293" v="3185" actId="14100"/>
           <ac:picMkLst>
             <pc:docMk/>
-            <pc:sldMk cId="1597710949" sldId="258"/>
-            <ac:picMk id="6" creationId="{B8A01A75-CDE7-2F3D-3B41-406DE2C5570D}"/>
+            <pc:sldMk cId="391511365" sldId="261"/>
+            <ac:picMk id="7" creationId="{7663A0AE-6559-AFC0-0285-39714AD36DB9}"/>
           </ac:picMkLst>
         </pc:picChg>
-        <pc:cxnChg chg="add mod">
-          <ac:chgData name="Minh Khôi Võ Tấn" userId="df010977c1c328cb" providerId="LiveId" clId="{021737E1-13EE-495B-A898-B29314BB33F8}" dt="2026-01-04T12:29:18.302" v="2231" actId="1076"/>
-          <ac:cxnSpMkLst>
-            <pc:docMk/>
-            <pc:sldMk cId="1597710949" sldId="258"/>
-            <ac:cxnSpMk id="12" creationId="{BFA19F96-57AC-D7CF-A84C-581C1DA8D989}"/>
-          </ac:cxnSpMkLst>
-        </pc:cxnChg>
-        <pc:cxnChg chg="add mod">
-          <ac:chgData name="Minh Khôi Võ Tấn" userId="df010977c1c328cb" providerId="LiveId" clId="{021737E1-13EE-495B-A898-B29314BB33F8}" dt="2026-01-04T12:29:13.363" v="2230" actId="1076"/>
-          <ac:cxnSpMkLst>
-            <pc:docMk/>
-            <pc:sldMk cId="1597710949" sldId="258"/>
-            <ac:cxnSpMk id="13" creationId="{2CAA3354-A7E7-1D93-B3ED-68DA1C3E35BE}"/>
-          </ac:cxnSpMkLst>
-        </pc:cxnChg>
-      </pc:sldChg>
-      <pc:sldChg chg="addSp delSp modSp new mod modNotesTx">
-        <pc:chgData name="Minh Khôi Võ Tấn" userId="df010977c1c328cb" providerId="LiveId" clId="{021737E1-13EE-495B-A898-B29314BB33F8}" dt="2026-01-18T13:05:50.700" v="3178" actId="1582"/>
-        <pc:sldMkLst>
-          <pc:docMk/>
-          <pc:sldMk cId="3350650080" sldId="259"/>
-        </pc:sldMkLst>
-        <pc:spChg chg="mod">
-          <ac:chgData name="Minh Khôi Võ Tấn" userId="df010977c1c328cb" providerId="LiveId" clId="{021737E1-13EE-495B-A898-B29314BB33F8}" dt="2026-01-04T12:30:04.618" v="2342" actId="20577"/>
-          <ac:spMkLst>
-            <pc:docMk/>
-            <pc:sldMk cId="3350650080" sldId="259"/>
-            <ac:spMk id="2" creationId="{FD52A742-864B-E99A-2F1D-36B43CB7A33A}"/>
-          </ac:spMkLst>
-        </pc:spChg>
-        <pc:spChg chg="add mod">
-          <ac:chgData name="Minh Khôi Võ Tấn" userId="df010977c1c328cb" providerId="LiveId" clId="{021737E1-13EE-495B-A898-B29314BB33F8}" dt="2026-01-17T11:14:53.352" v="3014" actId="1076"/>
-          <ac:spMkLst>
-            <pc:docMk/>
-            <pc:sldMk cId="3350650080" sldId="259"/>
-            <ac:spMk id="7" creationId="{4252A650-7296-CC77-2DA6-E23D047EFA81}"/>
-          </ac:spMkLst>
-        </pc:spChg>
-        <pc:spChg chg="add mod">
-          <ac:chgData name="Minh Khôi Võ Tấn" userId="df010977c1c328cb" providerId="LiveId" clId="{021737E1-13EE-495B-A898-B29314BB33F8}" dt="2026-01-18T13:03:29.030" v="3153" actId="404"/>
-          <ac:spMkLst>
-            <pc:docMk/>
-            <pc:sldMk cId="3350650080" sldId="259"/>
-            <ac:spMk id="10" creationId="{CAC7B3F9-E06B-0982-126C-CDC88CC0ACC5}"/>
-          </ac:spMkLst>
-        </pc:spChg>
-        <pc:spChg chg="add mod">
-          <ac:chgData name="Minh Khôi Võ Tấn" userId="df010977c1c328cb" providerId="LiveId" clId="{021737E1-13EE-495B-A898-B29314BB33F8}" dt="2026-01-17T11:14:59.726" v="3016" actId="1076"/>
-          <ac:spMkLst>
-            <pc:docMk/>
-            <pc:sldMk cId="3350650080" sldId="259"/>
-            <ac:spMk id="12" creationId="{584B77D8-5F7F-E09E-F2D1-21730F62571F}"/>
-          </ac:spMkLst>
-        </pc:spChg>
-        <pc:spChg chg="add mod">
-          <ac:chgData name="Minh Khôi Võ Tấn" userId="df010977c1c328cb" providerId="LiveId" clId="{021737E1-13EE-495B-A898-B29314BB33F8}" dt="2026-01-18T13:04:20.007" v="3165" actId="1076"/>
-          <ac:spMkLst>
-            <pc:docMk/>
-            <pc:sldMk cId="3350650080" sldId="259"/>
-            <ac:spMk id="14" creationId="{C3C72322-7C67-1410-B9C8-D6D01FAC5398}"/>
-          </ac:spMkLst>
-        </pc:spChg>
-        <pc:spChg chg="add mod">
-          <ac:chgData name="Minh Khôi Võ Tấn" userId="df010977c1c328cb" providerId="LiveId" clId="{021737E1-13EE-495B-A898-B29314BB33F8}" dt="2026-01-17T11:15:21.454" v="3021" actId="1076"/>
-          <ac:spMkLst>
-            <pc:docMk/>
-            <pc:sldMk cId="3350650080" sldId="259"/>
-            <ac:spMk id="15" creationId="{1F9F617B-3D75-D0C9-7A88-43BBAA5D62D9}"/>
-          </ac:spMkLst>
-        </pc:spChg>
-        <pc:spChg chg="add mod">
-          <ac:chgData name="Minh Khôi Võ Tấn" userId="df010977c1c328cb" providerId="LiveId" clId="{021737E1-13EE-495B-A898-B29314BB33F8}" dt="2026-01-18T13:04:01.840" v="3161" actId="1076"/>
-          <ac:spMkLst>
-            <pc:docMk/>
-            <pc:sldMk cId="3350650080" sldId="259"/>
-            <ac:spMk id="16" creationId="{01A38383-6B5A-4E4A-EBA8-E839180477B4}"/>
-          </ac:spMkLst>
-        </pc:spChg>
-        <pc:spChg chg="mod">
-          <ac:chgData name="Minh Khôi Võ Tấn" userId="df010977c1c328cb" providerId="LiveId" clId="{021737E1-13EE-495B-A898-B29314BB33F8}" dt="2026-01-18T13:04:16.713" v="3164" actId="1076"/>
-          <ac:spMkLst>
-            <pc:docMk/>
-            <pc:sldMk cId="3350650080" sldId="259"/>
-            <ac:spMk id="17" creationId="{CAF01C07-758E-7BDD-9450-1770DDB861BA}"/>
-          </ac:spMkLst>
-        </pc:spChg>
-        <pc:spChg chg="add mod">
-          <ac:chgData name="Minh Khôi Võ Tấn" userId="df010977c1c328cb" providerId="LiveId" clId="{021737E1-13EE-495B-A898-B29314BB33F8}" dt="2026-01-04T12:47:37.371" v="2425" actId="1076"/>
-          <ac:spMkLst>
-            <pc:docMk/>
-            <pc:sldMk cId="3350650080" sldId="259"/>
-            <ac:spMk id="19" creationId="{633120C8-955C-C7C4-7F9E-F1E0347BB4A7}"/>
-          </ac:spMkLst>
-        </pc:spChg>
-        <pc:spChg chg="mod">
-          <ac:chgData name="Minh Khôi Võ Tấn" userId="df010977c1c328cb" providerId="LiveId" clId="{021737E1-13EE-495B-A898-B29314BB33F8}" dt="2026-01-04T12:47:52.613" v="2428" actId="1076"/>
-          <ac:spMkLst>
-            <pc:docMk/>
-            <pc:sldMk cId="3350650080" sldId="259"/>
-            <ac:spMk id="20" creationId="{30E5171B-7D67-5A79-BB61-16E286CA41D3}"/>
-          </ac:spMkLst>
-        </pc:spChg>
-        <pc:spChg chg="mod">
-          <ac:chgData name="Minh Khôi Võ Tấn" userId="df010977c1c328cb" providerId="LiveId" clId="{021737E1-13EE-495B-A898-B29314BB33F8}" dt="2026-01-04T12:47:52.613" v="2428" actId="1076"/>
-          <ac:spMkLst>
-            <pc:docMk/>
-            <pc:sldMk cId="3350650080" sldId="259"/>
-            <ac:spMk id="21" creationId="{79411552-C1E1-9514-8414-C538B767463D}"/>
-          </ac:spMkLst>
-        </pc:spChg>
-        <pc:spChg chg="add mod">
-          <ac:chgData name="Minh Khôi Võ Tấn" userId="df010977c1c328cb" providerId="LiveId" clId="{021737E1-13EE-495B-A898-B29314BB33F8}" dt="2026-01-17T11:17:53.010" v="3130" actId="1076"/>
-          <ac:spMkLst>
-            <pc:docMk/>
-            <pc:sldMk cId="3350650080" sldId="259"/>
-            <ac:spMk id="27" creationId="{1F647E94-2332-2EDF-9BE0-AC5703F663B7}"/>
-          </ac:spMkLst>
-        </pc:spChg>
-        <pc:spChg chg="add mod">
-          <ac:chgData name="Minh Khôi Võ Tấn" userId="df010977c1c328cb" providerId="LiveId" clId="{021737E1-13EE-495B-A898-B29314BB33F8}" dt="2026-01-18T13:03:05.365" v="3148" actId="1076"/>
-          <ac:spMkLst>
-            <pc:docMk/>
-            <pc:sldMk cId="3350650080" sldId="259"/>
-            <ac:spMk id="32" creationId="{56E06A4C-BA5C-A743-E89B-546E3506E9EF}"/>
-          </ac:spMkLst>
-        </pc:spChg>
-        <pc:spChg chg="add mod">
-          <ac:chgData name="Minh Khôi Võ Tấn" userId="df010977c1c328cb" providerId="LiveId" clId="{021737E1-13EE-495B-A898-B29314BB33F8}" dt="2026-01-18T13:03:16.838" v="3151" actId="14100"/>
-          <ac:spMkLst>
-            <pc:docMk/>
-            <pc:sldMk cId="3350650080" sldId="259"/>
-            <ac:spMk id="33" creationId="{FBBA6943-D7BA-368A-BA6C-37B2235EB328}"/>
-          </ac:spMkLst>
-        </pc:spChg>
-        <pc:spChg chg="add mod">
-          <ac:chgData name="Minh Khôi Võ Tấn" userId="df010977c1c328cb" providerId="LiveId" clId="{021737E1-13EE-495B-A898-B29314BB33F8}" dt="2026-01-18T13:03:12.950" v="3150" actId="1076"/>
-          <ac:spMkLst>
-            <pc:docMk/>
-            <pc:sldMk cId="3350650080" sldId="259"/>
-            <ac:spMk id="43" creationId="{F9E22DE9-98BE-E4E1-A8F0-5066BDFDE13A}"/>
-          </ac:spMkLst>
-        </pc:spChg>
-        <pc:spChg chg="add mod">
-          <ac:chgData name="Minh Khôi Võ Tấn" userId="df010977c1c328cb" providerId="LiveId" clId="{021737E1-13EE-495B-A898-B29314BB33F8}" dt="2026-01-18T13:04:55.292" v="3171" actId="1076"/>
-          <ac:spMkLst>
-            <pc:docMk/>
-            <pc:sldMk cId="3350650080" sldId="259"/>
-            <ac:spMk id="47" creationId="{94F04050-940F-6A10-EF99-C8E01DB016A8}"/>
-          </ac:spMkLst>
-        </pc:spChg>
-        <pc:spChg chg="add mod">
-          <ac:chgData name="Minh Khôi Võ Tấn" userId="df010977c1c328cb" providerId="LiveId" clId="{021737E1-13EE-495B-A898-B29314BB33F8}" dt="2026-01-18T13:04:58.134" v="3172" actId="1076"/>
-          <ac:spMkLst>
-            <pc:docMk/>
-            <pc:sldMk cId="3350650080" sldId="259"/>
-            <ac:spMk id="48" creationId="{3D2BDE8E-D0FD-4543-1E92-E9FDF086C91D}"/>
-          </ac:spMkLst>
-        </pc:spChg>
-        <pc:spChg chg="add mod">
-          <ac:chgData name="Minh Khôi Võ Tấn" userId="df010977c1c328cb" providerId="LiveId" clId="{021737E1-13EE-495B-A898-B29314BB33F8}" dt="2026-01-17T11:18:23.990" v="3143" actId="1076"/>
-          <ac:spMkLst>
-            <pc:docMk/>
-            <pc:sldMk cId="3350650080" sldId="259"/>
-            <ac:spMk id="57" creationId="{6817932C-E353-2ABD-BD01-0DCF09E0AFE0}"/>
-          </ac:spMkLst>
-        </pc:spChg>
-        <pc:cxnChg chg="mod">
-          <ac:chgData name="Minh Khôi Võ Tấn" userId="df010977c1c328cb" providerId="LiveId" clId="{021737E1-13EE-495B-A898-B29314BB33F8}" dt="2026-01-17T11:15:03.792" v="3017" actId="1076"/>
-          <ac:cxnSpMkLst>
-            <pc:docMk/>
-            <pc:sldMk cId="3350650080" sldId="259"/>
-            <ac:cxnSpMk id="11" creationId="{65395CCC-1345-130C-78FE-2D74077CF771}"/>
-          </ac:cxnSpMkLst>
-        </pc:cxnChg>
-        <pc:cxnChg chg="mod">
-          <ac:chgData name="Minh Khôi Võ Tấn" userId="df010977c1c328cb" providerId="LiveId" clId="{021737E1-13EE-495B-A898-B29314BB33F8}" dt="2026-01-18T13:04:20.007" v="3165" actId="1076"/>
-          <ac:cxnSpMkLst>
-            <pc:docMk/>
-            <pc:sldMk cId="3350650080" sldId="259"/>
-            <ac:cxnSpMk id="13" creationId="{BED4831F-F02B-6B17-1173-DC0265D5BF25}"/>
-          </ac:cxnSpMkLst>
-        </pc:cxnChg>
-        <pc:cxnChg chg="mod">
-          <ac:chgData name="Minh Khôi Võ Tấn" userId="df010977c1c328cb" providerId="LiveId" clId="{021737E1-13EE-495B-A898-B29314BB33F8}" dt="2026-01-04T12:47:52.613" v="2428" actId="1076"/>
-          <ac:cxnSpMkLst>
-            <pc:docMk/>
-            <pc:sldMk cId="3350650080" sldId="259"/>
-            <ac:cxnSpMk id="22" creationId="{618E2246-55EF-1D6C-0AE6-310120099B00}"/>
-          </ac:cxnSpMkLst>
-        </pc:cxnChg>
-        <pc:cxnChg chg="mod">
-          <ac:chgData name="Minh Khôi Võ Tấn" userId="df010977c1c328cb" providerId="LiveId" clId="{021737E1-13EE-495B-A898-B29314BB33F8}" dt="2026-01-04T12:47:52.613" v="2428" actId="1076"/>
-          <ac:cxnSpMkLst>
-            <pc:docMk/>
-            <pc:sldMk cId="3350650080" sldId="259"/>
-            <ac:cxnSpMk id="23" creationId="{B2BCB7FD-B802-7E27-7614-2DDD05A76D42}"/>
-          </ac:cxnSpMkLst>
-        </pc:cxnChg>
-        <pc:cxnChg chg="mod">
-          <ac:chgData name="Minh Khôi Võ Tấn" userId="df010977c1c328cb" providerId="LiveId" clId="{021737E1-13EE-495B-A898-B29314BB33F8}" dt="2026-01-17T11:18:12.310" v="3135" actId="14100"/>
-          <ac:cxnSpMkLst>
-            <pc:docMk/>
-            <pc:sldMk cId="3350650080" sldId="259"/>
-            <ac:cxnSpMk id="28" creationId="{B3F15997-E796-A8CE-350A-D35E91F419B3}"/>
-          </ac:cxnSpMkLst>
-        </pc:cxnChg>
-        <pc:cxnChg chg="mod">
-          <ac:chgData name="Minh Khôi Võ Tấn" userId="df010977c1c328cb" providerId="LiveId" clId="{021737E1-13EE-495B-A898-B29314BB33F8}" dt="2026-01-17T11:18:09.712" v="3134" actId="14100"/>
-          <ac:cxnSpMkLst>
-            <pc:docMk/>
-            <pc:sldMk cId="3350650080" sldId="259"/>
-            <ac:cxnSpMk id="29" creationId="{082CB4E3-47AE-AD8B-7AFA-D55F8ED38671}"/>
-          </ac:cxnSpMkLst>
-        </pc:cxnChg>
-        <pc:cxnChg chg="add mod">
-          <ac:chgData name="Minh Khôi Võ Tấn" userId="df010977c1c328cb" providerId="LiveId" clId="{021737E1-13EE-495B-A898-B29314BB33F8}" dt="2026-01-18T13:04:20.007" v="3165" actId="1076"/>
-          <ac:cxnSpMkLst>
-            <pc:docMk/>
-            <pc:sldMk cId="3350650080" sldId="259"/>
-            <ac:cxnSpMk id="49" creationId="{18E0258B-74F8-7CDF-5A7D-6EAD580EF951}"/>
-          </ac:cxnSpMkLst>
-        </pc:cxnChg>
-        <pc:cxnChg chg="add mod">
-          <ac:chgData name="Minh Khôi Võ Tấn" userId="df010977c1c328cb" providerId="LiveId" clId="{021737E1-13EE-495B-A898-B29314BB33F8}" dt="2026-01-18T13:04:20.007" v="3165" actId="1076"/>
-          <ac:cxnSpMkLst>
-            <pc:docMk/>
-            <pc:sldMk cId="3350650080" sldId="259"/>
-            <ac:cxnSpMk id="51" creationId="{97B54F66-0D54-784D-B371-DA2990BB15E9}"/>
-          </ac:cxnSpMkLst>
-        </pc:cxnChg>
-        <pc:cxnChg chg="add mod">
-          <ac:chgData name="Minh Khôi Võ Tấn" userId="df010977c1c328cb" providerId="LiveId" clId="{021737E1-13EE-495B-A898-B29314BB33F8}" dt="2026-01-18T13:04:55.292" v="3171" actId="1076"/>
-          <ac:cxnSpMkLst>
-            <pc:docMk/>
-            <pc:sldMk cId="3350650080" sldId="259"/>
-            <ac:cxnSpMk id="77" creationId="{D038D8DA-B745-AC87-9470-3946B2BF13FE}"/>
-          </ac:cxnSpMkLst>
-        </pc:cxnChg>
-        <pc:cxnChg chg="add mod">
-          <ac:chgData name="Minh Khôi Võ Tấn" userId="df010977c1c328cb" providerId="LiveId" clId="{021737E1-13EE-495B-A898-B29314BB33F8}" dt="2026-01-18T13:05:50.700" v="3178" actId="1582"/>
-          <ac:cxnSpMkLst>
-            <pc:docMk/>
-            <pc:sldMk cId="3350650080" sldId="259"/>
-            <ac:cxnSpMk id="79" creationId="{959147C8-C094-8AE8-1A6F-813EAE2EDD4A}"/>
-          </ac:cxnSpMkLst>
-        </pc:cxnChg>
-        <pc:cxnChg chg="add mod">
-          <ac:chgData name="Minh Khôi Võ Tấn" userId="df010977c1c328cb" providerId="LiveId" clId="{021737E1-13EE-495B-A898-B29314BB33F8}" dt="2026-01-18T13:05:45.942" v="3177" actId="14100"/>
-          <ac:cxnSpMkLst>
-            <pc:docMk/>
-            <pc:sldMk cId="3350650080" sldId="259"/>
-            <ac:cxnSpMk id="82" creationId="{BA5A9BA2-D128-4D16-750A-7AF6BF95ABAB}"/>
-          </ac:cxnSpMkLst>
-        </pc:cxnChg>
-      </pc:sldChg>
-      <pc:sldChg chg="addSp delSp modSp new mod">
-        <pc:chgData name="Minh Khôi Võ Tấn" userId="df010977c1c328cb" providerId="LiveId" clId="{021737E1-13EE-495B-A898-B29314BB33F8}" dt="2026-01-10T05:20:42.055" v="2929" actId="14100"/>
-        <pc:sldMkLst>
-          <pc:docMk/>
-          <pc:sldMk cId="3593306569" sldId="260"/>
-        </pc:sldMkLst>
-        <pc:spChg chg="mod">
-          <ac:chgData name="Minh Khôi Võ Tấn" userId="df010977c1c328cb" providerId="LiveId" clId="{021737E1-13EE-495B-A898-B29314BB33F8}" dt="2026-01-04T12:59:13.655" v="2502" actId="20577"/>
-          <ac:spMkLst>
-            <pc:docMk/>
-            <pc:sldMk cId="3593306569" sldId="260"/>
-            <ac:spMk id="2" creationId="{0ED1C4E5-C12F-539B-738E-2B46912D597E}"/>
-          </ac:spMkLst>
-        </pc:spChg>
-        <pc:spChg chg="add mod ord">
-          <ac:chgData name="Minh Khôi Võ Tấn" userId="df010977c1c328cb" providerId="LiveId" clId="{021737E1-13EE-495B-A898-B29314BB33F8}" dt="2026-01-10T05:20:42.055" v="2929" actId="14100"/>
-          <ac:spMkLst>
-            <pc:docMk/>
-            <pc:sldMk cId="3593306569" sldId="260"/>
-            <ac:spMk id="10" creationId="{11CBAFB8-22C0-37F7-8264-46046E043BDB}"/>
-          </ac:spMkLst>
-        </pc:spChg>
-        <pc:spChg chg="add mod ord">
-          <ac:chgData name="Minh Khôi Võ Tấn" userId="df010977c1c328cb" providerId="LiveId" clId="{021737E1-13EE-495B-A898-B29314BB33F8}" dt="2026-01-10T05:20:32.604" v="2928" actId="14100"/>
-          <ac:spMkLst>
-            <pc:docMk/>
-            <pc:sldMk cId="3593306569" sldId="260"/>
-            <ac:spMk id="12" creationId="{3F6F5843-ECE7-5D3A-5DA5-4482E454297D}"/>
-          </ac:spMkLst>
-        </pc:spChg>
-        <pc:picChg chg="add mod">
-          <ac:chgData name="Minh Khôi Võ Tấn" userId="df010977c1c328cb" providerId="LiveId" clId="{021737E1-13EE-495B-A898-B29314BB33F8}" dt="2026-01-10T05:20:23.424" v="2926" actId="1076"/>
+        <pc:picChg chg="mod">
+          <ac:chgData name="Minh Khôi Võ Tấn" userId="df010977c1c328cb" providerId="LiveId" clId="{021737E1-13EE-495B-A898-B29314BB33F8}" dt="2026-03-28T03:56:06.639" v="3186" actId="14100"/>
           <ac:picMkLst>
             <pc:docMk/>
-            <pc:sldMk cId="3593306569" sldId="260"/>
-            <ac:picMk id="14" creationId="{9609EADD-3FF5-28C0-C43C-8E17E950214E}"/>
-          </ac:picMkLst>
-        </pc:picChg>
-      </pc:sldChg>
-      <pc:sldChg chg="addSp delSp modSp new mod">
-        <pc:chgData name="Minh Khôi Võ Tấn" userId="df010977c1c328cb" providerId="LiveId" clId="{021737E1-13EE-495B-A898-B29314BB33F8}" dt="2026-01-10T05:22:20.269" v="2963" actId="1076"/>
-        <pc:sldMkLst>
-          <pc:docMk/>
-          <pc:sldMk cId="294093517" sldId="261"/>
-        </pc:sldMkLst>
-        <pc:spChg chg="mod">
-          <ac:chgData name="Minh Khôi Võ Tấn" userId="df010977c1c328cb" providerId="LiveId" clId="{021737E1-13EE-495B-A898-B29314BB33F8}" dt="2026-01-10T05:21:57.562" v="2957" actId="20577"/>
-          <ac:spMkLst>
-            <pc:docMk/>
-            <pc:sldMk cId="294093517" sldId="261"/>
-            <ac:spMk id="2" creationId="{97237E4C-AE4C-D056-1C19-35C4D30698AC}"/>
-          </ac:spMkLst>
-        </pc:spChg>
-        <pc:spChg chg="add mod">
-          <ac:chgData name="Minh Khôi Võ Tấn" userId="df010977c1c328cb" providerId="LiveId" clId="{021737E1-13EE-495B-A898-B29314BB33F8}" dt="2026-01-10T05:22:20.269" v="2963" actId="1076"/>
-          <ac:spMkLst>
-            <pc:docMk/>
-            <pc:sldMk cId="294093517" sldId="261"/>
-            <ac:spMk id="8" creationId="{C64E1DF5-BEC0-57AC-FD32-6ECE4816000E}"/>
-          </ac:spMkLst>
-        </pc:spChg>
-        <pc:picChg chg="add mod">
-          <ac:chgData name="Minh Khôi Võ Tấn" userId="df010977c1c328cb" providerId="LiveId" clId="{021737E1-13EE-495B-A898-B29314BB33F8}" dt="2026-01-10T05:22:13.233" v="2961" actId="1076"/>
-          <ac:picMkLst>
-            <pc:docMk/>
-            <pc:sldMk cId="294093517" sldId="261"/>
-            <ac:picMk id="7" creationId="{69FC3C02-9817-DB4D-ED5D-91C72174FFBF}"/>
+            <pc:sldMk cId="391511365" sldId="261"/>
+            <ac:picMk id="14" creationId="{C5CC2488-F8BB-C072-807D-C2A5FC0C7804}"/>
           </ac:picMkLst>
         </pc:picChg>
       </pc:sldChg>
     </pc:docChg>
   </pc:docChgLst>
-  <pc:docChgLst>
-    <pc:chgData name="Minh Khôi Võ Tấn" userId="df010977c1c328cb" providerId="Windows Live" clId="Web-{7D8275EE-B700-D7F4-297E-EB361C7BC9BE}"/>
-    <pc:docChg chg="modSld">
-      <pc:chgData name="Minh Khôi Võ Tấn" userId="df010977c1c328cb" providerId="Windows Live" clId="Web-{7D8275EE-B700-D7F4-297E-EB361C7BC9BE}" dt="2026-01-30T08:09:57.139" v="62" actId="14100"/>
-      <pc:docMkLst>
-        <pc:docMk/>
-      </pc:docMkLst>
-      <pc:sldChg chg="addSp delSp modSp">
-        <pc:chgData name="Minh Khôi Võ Tấn" userId="df010977c1c328cb" providerId="Windows Live" clId="Web-{7D8275EE-B700-D7F4-297E-EB361C7BC9BE}" dt="2026-01-30T08:09:57.139" v="62" actId="14100"/>
-        <pc:sldMkLst>
-          <pc:docMk/>
-          <pc:sldMk cId="3350650080" sldId="259"/>
-        </pc:sldMkLst>
-        <pc:spChg chg="add mod">
-          <ac:chgData name="Minh Khôi Võ Tấn" userId="df010977c1c328cb" providerId="Windows Live" clId="Web-{7D8275EE-B700-D7F4-297E-EB361C7BC9BE}" dt="2026-01-30T08:09:03.653" v="55" actId="14100"/>
-          <ac:spMkLst>
-            <pc:docMk/>
-            <pc:sldMk cId="3350650080" sldId="259"/>
-            <ac:spMk id="3" creationId="{E58FC05A-5382-AEB4-D802-7B31B6BE6F0D}"/>
-          </ac:spMkLst>
-        </pc:spChg>
-        <pc:spChg chg="mod">
-          <ac:chgData name="Minh Khôi Võ Tấn" userId="df010977c1c328cb" providerId="Windows Live" clId="Web-{7D8275EE-B700-D7F4-297E-EB361C7BC9BE}" dt="2026-01-30T07:27:36.955" v="34" actId="1076"/>
-          <ac:spMkLst>
-            <pc:docMk/>
-            <pc:sldMk cId="3350650080" sldId="259"/>
-            <ac:spMk id="7" creationId="{4252A650-7296-CC77-2DA6-E23D047EFA81}"/>
-          </ac:spMkLst>
-        </pc:spChg>
-        <pc:spChg chg="del">
-          <ac:chgData name="Minh Khôi Võ Tấn" userId="df010977c1c328cb" providerId="Windows Live" clId="Web-{7D8275EE-B700-D7F4-297E-EB361C7BC9BE}" dt="2026-01-30T07:27:49.158" v="38"/>
-          <ac:spMkLst>
-            <pc:docMk/>
-            <pc:sldMk cId="3350650080" sldId="259"/>
-            <ac:spMk id="9" creationId="{F6CDC67F-2245-F026-6901-378F33C85B43}"/>
-          </ac:spMkLst>
-        </pc:spChg>
-        <pc:spChg chg="mod">
-          <ac:chgData name="Minh Khôi Võ Tấn" userId="df010977c1c328cb" providerId="Windows Live" clId="Web-{7D8275EE-B700-D7F4-297E-EB361C7BC9BE}" dt="2026-01-30T07:26:48.454" v="22" actId="1076"/>
-          <ac:spMkLst>
-            <pc:docMk/>
-            <pc:sldMk cId="3350650080" sldId="259"/>
-            <ac:spMk id="10" creationId="{CAC7B3F9-E06B-0982-126C-CDC88CC0ACC5}"/>
-          </ac:spMkLst>
-        </pc:spChg>
-        <pc:spChg chg="mod">
-          <ac:chgData name="Minh Khôi Võ Tấn" userId="df010977c1c328cb" providerId="Windows Live" clId="Web-{7D8275EE-B700-D7F4-297E-EB361C7BC9BE}" dt="2026-01-30T07:27:41.564" v="35" actId="1076"/>
-          <ac:spMkLst>
-            <pc:docMk/>
-            <pc:sldMk cId="3350650080" sldId="259"/>
-            <ac:spMk id="12" creationId="{584B77D8-5F7F-E09E-F2D1-21730F62571F}"/>
-          </ac:spMkLst>
-        </pc:spChg>
-        <pc:spChg chg="mod">
-          <ac:chgData name="Minh Khôi Võ Tấn" userId="df010977c1c328cb" providerId="Windows Live" clId="Web-{7D8275EE-B700-D7F4-297E-EB361C7BC9BE}" dt="2026-01-30T07:26:30.610" v="2" actId="1076"/>
-          <ac:spMkLst>
-            <pc:docMk/>
-            <pc:sldMk cId="3350650080" sldId="259"/>
-            <ac:spMk id="14" creationId="{C3C72322-7C67-1410-B9C8-D6D01FAC5398}"/>
-          </ac:spMkLst>
-        </pc:spChg>
-        <pc:spChg chg="mod">
-          <ac:chgData name="Minh Khôi Võ Tấn" userId="df010977c1c328cb" providerId="Windows Live" clId="Web-{7D8275EE-B700-D7F4-297E-EB361C7BC9BE}" dt="2026-01-30T07:26:30.626" v="3" actId="1076"/>
-          <ac:spMkLst>
-            <pc:docMk/>
-            <pc:sldMk cId="3350650080" sldId="259"/>
-            <ac:spMk id="15" creationId="{1F9F617B-3D75-D0C9-7A88-43BBAA5D62D9}"/>
-          </ac:spMkLst>
-        </pc:spChg>
-        <pc:spChg chg="mod">
-          <ac:chgData name="Minh Khôi Võ Tấn" userId="df010977c1c328cb" providerId="Windows Live" clId="Web-{7D8275EE-B700-D7F4-297E-EB361C7BC9BE}" dt="2026-01-30T07:26:30.673" v="4" actId="1076"/>
-          <ac:spMkLst>
-            <pc:docMk/>
-            <pc:sldMk cId="3350650080" sldId="259"/>
-            <ac:spMk id="16" creationId="{01A38383-6B5A-4E4A-EBA8-E839180477B4}"/>
-          </ac:spMkLst>
-        </pc:spChg>
-        <pc:spChg chg="mod">
-          <ac:chgData name="Minh Khôi Võ Tấn" userId="df010977c1c328cb" providerId="Windows Live" clId="Web-{7D8275EE-B700-D7F4-297E-EB361C7BC9BE}" dt="2026-01-30T07:26:30.720" v="5" actId="1076"/>
-          <ac:spMkLst>
-            <pc:docMk/>
-            <pc:sldMk cId="3350650080" sldId="259"/>
-            <ac:spMk id="17" creationId="{CAF01C07-758E-7BDD-9450-1770DDB861BA}"/>
-          </ac:spMkLst>
-        </pc:spChg>
-        <pc:spChg chg="mod">
-          <ac:chgData name="Minh Khôi Võ Tấn" userId="df010977c1c328cb" providerId="Windows Live" clId="Web-{7D8275EE-B700-D7F4-297E-EB361C7BC9BE}" dt="2026-01-30T07:26:30.767" v="6" actId="1076"/>
-          <ac:spMkLst>
-            <pc:docMk/>
-            <pc:sldMk cId="3350650080" sldId="259"/>
-            <ac:spMk id="19" creationId="{633120C8-955C-C7C4-7F9E-F1E0347BB4A7}"/>
-          </ac:spMkLst>
-        </pc:spChg>
-        <pc:spChg chg="mod">
-          <ac:chgData name="Minh Khôi Võ Tấn" userId="df010977c1c328cb" providerId="Windows Live" clId="Web-{7D8275EE-B700-D7F4-297E-EB361C7BC9BE}" dt="2026-01-30T07:26:30.814" v="7" actId="1076"/>
-          <ac:spMkLst>
-            <pc:docMk/>
-            <pc:sldMk cId="3350650080" sldId="259"/>
-            <ac:spMk id="20" creationId="{30E5171B-7D67-5A79-BB61-16E286CA41D3}"/>
-          </ac:spMkLst>
-        </pc:spChg>
-        <pc:spChg chg="mod">
-          <ac:chgData name="Minh Khôi Võ Tấn" userId="df010977c1c328cb" providerId="Windows Live" clId="Web-{7D8275EE-B700-D7F4-297E-EB361C7BC9BE}" dt="2026-01-30T07:26:30.860" v="8" actId="1076"/>
-          <ac:spMkLst>
-            <pc:docMk/>
-            <pc:sldMk cId="3350650080" sldId="259"/>
-            <ac:spMk id="21" creationId="{79411552-C1E1-9514-8414-C538B767463D}"/>
-          </ac:spMkLst>
-        </pc:spChg>
-        <pc:spChg chg="mod">
-          <ac:chgData name="Minh Khôi Võ Tấn" userId="df010977c1c328cb" providerId="Windows Live" clId="Web-{7D8275EE-B700-D7F4-297E-EB361C7BC9BE}" dt="2026-01-30T07:26:41.501" v="20" actId="1076"/>
-          <ac:spMkLst>
-            <pc:docMk/>
-            <pc:sldMk cId="3350650080" sldId="259"/>
-            <ac:spMk id="27" creationId="{1F647E94-2332-2EDF-9BE0-AC5703F663B7}"/>
-          </ac:spMkLst>
-        </pc:spChg>
-        <pc:spChg chg="mod">
-          <ac:chgData name="Minh Khôi Võ Tấn" userId="df010977c1c328cb" providerId="Windows Live" clId="Web-{7D8275EE-B700-D7F4-297E-EB361C7BC9BE}" dt="2026-01-30T07:28:20.705" v="47" actId="1076"/>
-          <ac:spMkLst>
-            <pc:docMk/>
-            <pc:sldMk cId="3350650080" sldId="259"/>
-            <ac:spMk id="32" creationId="{56E06A4C-BA5C-A743-E89B-546E3506E9EF}"/>
-          </ac:spMkLst>
-        </pc:spChg>
-        <pc:spChg chg="mod">
-          <ac:chgData name="Minh Khôi Võ Tấn" userId="df010977c1c328cb" providerId="Windows Live" clId="Web-{7D8275EE-B700-D7F4-297E-EB361C7BC9BE}" dt="2026-01-30T07:28:24.518" v="48" actId="1076"/>
-          <ac:spMkLst>
-            <pc:docMk/>
-            <pc:sldMk cId="3350650080" sldId="259"/>
-            <ac:spMk id="33" creationId="{FBBA6943-D7BA-368A-BA6C-37B2235EB328}"/>
-          </ac:spMkLst>
-        </pc:spChg>
-        <pc:spChg chg="mod">
-          <ac:chgData name="Minh Khôi Võ Tấn" userId="df010977c1c328cb" providerId="Windows Live" clId="Web-{7D8275EE-B700-D7F4-297E-EB361C7BC9BE}" dt="2026-01-30T07:28:05.814" v="45" actId="1076"/>
-          <ac:spMkLst>
-            <pc:docMk/>
-            <pc:sldMk cId="3350650080" sldId="259"/>
-            <ac:spMk id="43" creationId="{F9E22DE9-98BE-E4E1-A8F0-5066BDFDE13A}"/>
-          </ac:spMkLst>
-        </pc:spChg>
-        <pc:spChg chg="del">
-          <ac:chgData name="Minh Khôi Võ Tấn" userId="df010977c1c328cb" providerId="Windows Live" clId="Web-{7D8275EE-B700-D7F4-297E-EB361C7BC9BE}" dt="2026-01-30T07:27:47.861" v="37"/>
-          <ac:spMkLst>
-            <pc:docMk/>
-            <pc:sldMk cId="3350650080" sldId="259"/>
-            <ac:spMk id="45" creationId="{25F507D2-1107-C579-61E2-15466E8CEC22}"/>
-          </ac:spMkLst>
-        </pc:spChg>
-        <pc:spChg chg="mod">
-          <ac:chgData name="Minh Khôi Võ Tấn" userId="df010977c1c328cb" providerId="Windows Live" clId="Web-{7D8275EE-B700-D7F4-297E-EB361C7BC9BE}" dt="2026-01-30T07:26:31.001" v="15" actId="1076"/>
-          <ac:spMkLst>
-            <pc:docMk/>
-            <pc:sldMk cId="3350650080" sldId="259"/>
-            <ac:spMk id="47" creationId="{94F04050-940F-6A10-EF99-C8E01DB016A8}"/>
-          </ac:spMkLst>
-        </pc:spChg>
-        <pc:spChg chg="mod">
-          <ac:chgData name="Minh Khôi Võ Tấn" userId="df010977c1c328cb" providerId="Windows Live" clId="Web-{7D8275EE-B700-D7F4-297E-EB361C7BC9BE}" dt="2026-01-30T07:26:31.017" v="16" actId="1076"/>
-          <ac:spMkLst>
-            <pc:docMk/>
-            <pc:sldMk cId="3350650080" sldId="259"/>
-            <ac:spMk id="48" creationId="{3D2BDE8E-D0FD-4543-1E92-E9FDF086C91D}"/>
-          </ac:spMkLst>
-        </pc:spChg>
-        <pc:spChg chg="mod">
-          <ac:chgData name="Minh Khôi Võ Tấn" userId="df010977c1c328cb" providerId="Windows Live" clId="Web-{7D8275EE-B700-D7F4-297E-EB361C7BC9BE}" dt="2026-01-30T07:26:37.111" v="19" actId="1076"/>
-          <ac:spMkLst>
-            <pc:docMk/>
-            <pc:sldMk cId="3350650080" sldId="259"/>
-            <ac:spMk id="57" creationId="{6817932C-E353-2ABD-BD01-0DCF09E0AFE0}"/>
-          </ac:spMkLst>
-        </pc:spChg>
-        <pc:cxnChg chg="add del">
-          <ac:chgData name="Minh Khôi Võ Tấn" userId="df010977c1c328cb" providerId="Windows Live" clId="Web-{7D8275EE-B700-D7F4-297E-EB361C7BC9BE}" dt="2026-01-30T08:09:18.466" v="57"/>
-          <ac:cxnSpMkLst>
-            <pc:docMk/>
-            <pc:sldMk cId="3350650080" sldId="259"/>
-            <ac:cxnSpMk id="6" creationId="{3E4E0DEC-F158-399D-B731-D00A4DB0E7F8}"/>
-          </ac:cxnSpMkLst>
-        </pc:cxnChg>
-        <pc:cxnChg chg="del mod">
-          <ac:chgData name="Minh Khôi Võ Tấn" userId="df010977c1c328cb" providerId="Windows Live" clId="Web-{7D8275EE-B700-D7F4-297E-EB361C7BC9BE}" dt="2026-01-30T07:27:46.705" v="36"/>
-          <ac:cxnSpMkLst>
-            <pc:docMk/>
-            <pc:sldMk cId="3350650080" sldId="259"/>
-            <ac:cxnSpMk id="8" creationId="{B692CCDB-D6F2-DC5A-3C3D-F4E69B9A3FC1}"/>
-          </ac:cxnSpMkLst>
-        </pc:cxnChg>
-        <pc:cxnChg chg="mod">
-          <ac:chgData name="Minh Khôi Võ Tấn" userId="df010977c1c328cb" providerId="Windows Live" clId="Web-{7D8275EE-B700-D7F4-297E-EB361C7BC9BE}" dt="2026-01-30T07:27:36.955" v="34" actId="1076"/>
-          <ac:cxnSpMkLst>
-            <pc:docMk/>
-            <pc:sldMk cId="3350650080" sldId="259"/>
-            <ac:cxnSpMk id="11" creationId="{65395CCC-1345-130C-78FE-2D74077CF771}"/>
-          </ac:cxnSpMkLst>
-        </pc:cxnChg>
-        <pc:cxnChg chg="mod">
-          <ac:chgData name="Minh Khôi Võ Tấn" userId="df010977c1c328cb" providerId="Windows Live" clId="Web-{7D8275EE-B700-D7F4-297E-EB361C7BC9BE}" dt="2026-01-30T07:26:30.548" v="1" actId="1076"/>
-          <ac:cxnSpMkLst>
-            <pc:docMk/>
-            <pc:sldMk cId="3350650080" sldId="259"/>
-            <ac:cxnSpMk id="13" creationId="{BED4831F-F02B-6B17-1173-DC0265D5BF25}"/>
-          </ac:cxnSpMkLst>
-        </pc:cxnChg>
-        <pc:cxnChg chg="mod">
-          <ac:chgData name="Minh Khôi Võ Tấn" userId="df010977c1c328cb" providerId="Windows Live" clId="Web-{7D8275EE-B700-D7F4-297E-EB361C7BC9BE}" dt="2026-01-30T07:26:30.876" v="9" actId="1076"/>
-          <ac:cxnSpMkLst>
-            <pc:docMk/>
-            <pc:sldMk cId="3350650080" sldId="259"/>
-            <ac:cxnSpMk id="22" creationId="{618E2246-55EF-1D6C-0AE6-310120099B00}"/>
-          </ac:cxnSpMkLst>
-        </pc:cxnChg>
-        <pc:cxnChg chg="mod">
-          <ac:chgData name="Minh Khôi Võ Tấn" userId="df010977c1c328cb" providerId="Windows Live" clId="Web-{7D8275EE-B700-D7F4-297E-EB361C7BC9BE}" dt="2026-01-30T07:26:30.892" v="10" actId="1076"/>
-          <ac:cxnSpMkLst>
-            <pc:docMk/>
-            <pc:sldMk cId="3350650080" sldId="259"/>
-            <ac:cxnSpMk id="23" creationId="{B2BCB7FD-B802-7E27-7614-2DDD05A76D42}"/>
-          </ac:cxnSpMkLst>
-        </pc:cxnChg>
-        <pc:cxnChg chg="mod">
-          <ac:chgData name="Minh Khôi Võ Tấn" userId="df010977c1c328cb" providerId="Windows Live" clId="Web-{7D8275EE-B700-D7F4-297E-EB361C7BC9BE}" dt="2026-01-30T08:09:44.139" v="61" actId="14100"/>
-          <ac:cxnSpMkLst>
-            <pc:docMk/>
-            <pc:sldMk cId="3350650080" sldId="259"/>
-            <ac:cxnSpMk id="28" creationId="{B3F15997-E796-A8CE-350A-D35E91F419B3}"/>
-          </ac:cxnSpMkLst>
-        </pc:cxnChg>
-        <pc:cxnChg chg="mod">
-          <ac:chgData name="Minh Khôi Võ Tấn" userId="df010977c1c328cb" providerId="Windows Live" clId="Web-{7D8275EE-B700-D7F4-297E-EB361C7BC9BE}" dt="2026-01-30T08:09:57.139" v="62" actId="14100"/>
-          <ac:cxnSpMkLst>
-            <pc:docMk/>
-            <pc:sldMk cId="3350650080" sldId="259"/>
-            <ac:cxnSpMk id="29" creationId="{082CB4E3-47AE-AD8B-7AFA-D55F8ED38671}"/>
-          </ac:cxnSpMkLst>
-        </pc:cxnChg>
-        <pc:cxnChg chg="mod">
-          <ac:chgData name="Minh Khôi Võ Tấn" userId="df010977c1c328cb" providerId="Windows Live" clId="Web-{7D8275EE-B700-D7F4-297E-EB361C7BC9BE}" dt="2026-01-30T07:26:30.939" v="13" actId="1076"/>
-          <ac:cxnSpMkLst>
-            <pc:docMk/>
-            <pc:sldMk cId="3350650080" sldId="259"/>
-            <ac:cxnSpMk id="49" creationId="{18E0258B-74F8-7CDF-5A7D-6EAD580EF951}"/>
-          </ac:cxnSpMkLst>
-        </pc:cxnChg>
-        <pc:cxnChg chg="mod">
-          <ac:chgData name="Minh Khôi Võ Tấn" userId="df010977c1c328cb" providerId="Windows Live" clId="Web-{7D8275EE-B700-D7F4-297E-EB361C7BC9BE}" dt="2026-01-30T07:26:30.954" v="14" actId="1076"/>
-          <ac:cxnSpMkLst>
-            <pc:docMk/>
-            <pc:sldMk cId="3350650080" sldId="259"/>
-            <ac:cxnSpMk id="51" creationId="{97B54F66-0D54-784D-B371-DA2990BB15E9}"/>
-          </ac:cxnSpMkLst>
-        </pc:cxnChg>
-        <pc:cxnChg chg="mod">
-          <ac:chgData name="Minh Khôi Võ Tấn" userId="df010977c1c328cb" providerId="Windows Live" clId="Web-{7D8275EE-B700-D7F4-297E-EB361C7BC9BE}" dt="2026-01-30T07:26:17.048" v="0" actId="1076"/>
-          <ac:cxnSpMkLst>
-            <pc:docMk/>
-            <pc:sldMk cId="3350650080" sldId="259"/>
-            <ac:cxnSpMk id="77" creationId="{D038D8DA-B745-AC87-9470-3946B2BF13FE}"/>
-          </ac:cxnSpMkLst>
-        </pc:cxnChg>
-        <pc:cxnChg chg="mod">
-          <ac:chgData name="Minh Khôi Võ Tấn" userId="df010977c1c328cb" providerId="Windows Live" clId="Web-{7D8275EE-B700-D7F4-297E-EB361C7BC9BE}" dt="2026-01-30T07:26:31.032" v="17" actId="1076"/>
-          <ac:cxnSpMkLst>
-            <pc:docMk/>
-            <pc:sldMk cId="3350650080" sldId="259"/>
-            <ac:cxnSpMk id="79" creationId="{959147C8-C094-8AE8-1A6F-813EAE2EDD4A}"/>
-          </ac:cxnSpMkLst>
-        </pc:cxnChg>
-        <pc:cxnChg chg="mod">
-          <ac:chgData name="Minh Khôi Võ Tấn" userId="df010977c1c328cb" providerId="Windows Live" clId="Web-{7D8275EE-B700-D7F4-297E-EB361C7BC9BE}" dt="2026-01-30T07:26:31.048" v="18" actId="1076"/>
-          <ac:cxnSpMkLst>
-            <pc:docMk/>
-            <pc:sldMk cId="3350650080" sldId="259"/>
-            <ac:cxnSpMk id="82" creationId="{BA5A9BA2-D128-4D16-750A-7AF6BF95ABAB}"/>
-          </ac:cxnSpMkLst>
-        </pc:cxnChg>
-      </pc:sldChg>
-    </pc:docChg>
-  </pc:docChgLst>
 </pc:chgInfo>
+</file>
+
+<file path=ppt/ink/ink1.xml><?xml version="1.0" encoding="utf-8"?>
+<inkml:ink xmlns:inkml="http://www.w3.org/2003/InkML">
+  <inkml:definitions>
+    <inkml:context xml:id="ctx0">
+      <inkml:inkSource xml:id="inkSrc0">
+        <inkml:traceFormat>
+          <inkml:channel name="X" type="integer" min="-2.14748E9" max="2.14748E9" units="cm"/>
+          <inkml:channel name="Y" type="integer" min="-2.14748E9" max="2.14748E9" units="cm"/>
+          <inkml:channel name="F" type="integer" max="32767" units="dev"/>
+        </inkml:traceFormat>
+        <inkml:channelProperties>
+          <inkml:channelProperty channel="X" name="resolution" value="1000" units="1/cm"/>
+          <inkml:channelProperty channel="Y" name="resolution" value="1000" units="1/cm"/>
+          <inkml:channelProperty channel="F" name="resolution" value="0" units="1/dev"/>
+        </inkml:channelProperties>
+      </inkml:inkSource>
+      <inkml:timestamp xml:id="ts0" timeString="2026-03-28T04:05:31.399"/>
+    </inkml:context>
+    <inkml:brush xml:id="br0">
+      <inkml:brushProperty name="width" value="0.35" units="cm"/>
+      <inkml:brushProperty name="height" value="0.35" units="cm"/>
+      <inkml:brushProperty name="color" value="#E71224"/>
+    </inkml:brush>
+  </inkml:definitions>
+  <inkml:trace contextRef="#ctx0" brushRef="#br0">551 1 24575,'1'0'0,"1"1"0,-1-1 0,0 1 0,0 0 0,0 0 0,0-1 0,0 1 0,1 2 0,1-1 0,103 84 0,-85-72 0,0 0 0,0-2 0,37 15 0,-38-19 0,-12-6 0,0 1 0,-1-1 0,1 2 0,-1-1 0,0 1 0,7 5 0,-13-8 0,0 1 0,1-1 0,-1 0 0,0 1 0,0-1 0,0 0 0,0 1 0,-1 0 0,1-1 0,0 1 0,-1-1 0,1 1 0,-1 0 0,1-1 0,-1 1 0,0 0 0,0 0 0,0-1 0,0 1 0,0 0 0,0 0 0,0-1 0,0 1 0,-1 0 0,1 0 0,-1-1 0,1 1 0,-1-1 0,0 1 0,1 0 0,-1-1 0,-2 3 0,-5 3 0,-1 0 0,1 0 0,-2-1 0,1 0 0,-20 9 0,20-10 0,-22 10 0,-55 19 0,-36 1 0,20-11 0,91-22 0,1 2 0,-1 0 0,0 0 0,1 1 0,0 0 0,0 0 0,-12 10 0,19-12 0,0 0 0,0 0 0,-4 5 0,-7 7 0,-1-3 0,-25 15 0,9-6 0,30-21 0,-10 10 0,11-10 0,0 0 0,0 1 0,0-1 0,0 0 0,-1 0 0,1 1 0,0-1 0,0 0 0,0 1 0,0-1 0,0 0 0,0 0 0,0 1 0,0-1 0,0 0 0,0 1 0,0-1 0,0 0 0,0 1 0,0-1 0,0 0 0,0 1 0,0-1 0,0 0 0,0 0 0,1 1 0,-1-1 0,0 0 0,0 1 0,0-1 0,1 0 0,-1 0 0,0 0 0,0 1 0,0-1 0,1 0 0,-1 0 0,0 0 0,0 1 0,1-1 0,-1 0 0,14 7 0,0 0 0,28 10 0,-22-9 0,54 20 0,269 97 0,-314-115 0,258 98 0,-199-72 0,-46-20 0,-25-11 0,-13-3 0,1-1 0,0 1 0,0 0 0,-1 0 0,0 0 0,6 4 0,-10-6 0,0 0 0,0 0 0,0 0 0,1 0 0,-1 0 0,0 1 0,0-1 0,0 0 0,0 0 0,0 0 0,0 0 0,0 0 0,0 0 0,0 0 0,0 0 0,1 0 0,-1 1 0,0-1 0,0 0 0,0 0 0,0 0 0,0 0 0,0 0 0,0 0 0,0 1 0,0-1 0,0 0 0,0 0 0,0 0 0,0 0 0,0 0 0,0 0 0,0 1 0,0-1 0,0 0 0,0 0 0,0 0 0,0 0 0,-1 0 0,1 0 0,0 0 0,0 1 0,0-1 0,0 0 0,0 0 0,0 0 0,0 0 0,0 0 0,0 0 0,0 0 0,-1 0 0,1 0 0,0 0 0,0 0 0,0 0 0,0 1 0,0-1 0,0 0 0,-1 0 0,-8 2 0,9-2 0,-29 2 0,0 0 0,-31-3 0,16 0 0,-11 1 0,-1 2 0,-92 17 0,-142 43 0,124-29 0,70-14 0,40-7 0,-106 22 0,154-33 0,5 0 0,0-1 0,0 1 0,0-1 0,0 1 0,1 0 0,-1 0 0,0 1 0,-3 1 0,5-3 0,1 0 0,0 0 0,0 0 0,0 0 0,0 0 0,0 0 0,0 0 0,0 0 0,0 1 0,0-1 0,0 0 0,0 0 0,-1 0 0,1 0 0,0 0 0,0 0 0,0 0 0,0 0 0,0 0 0,0 0 0,0 1 0,0-1 0,0 0 0,0 0 0,0 0 0,0 0 0,0 0 0,0 0 0,0 0 0,0 0 0,0 0 0,0 1 0,0-1 0,0 0 0,0 0 0,0 0 0,0 0 0,0 0 0,0 0 0,0 0 0,0 0 0,1 0 0,-1 1 0,0-1 0,0 0 0,0 0 0,0 0 0,0 0 0,0 0 0,0 0 0,0 0 0,0 0 0,0 0 0,0 0 0,1 0 0,-1 0 0,0 0 0,0 0 0,0 0 0,0 0 0,7 2 0,20 2 0,23 3 0,187 70 0,-173-54 0,49 19 0,102 34 0,-174-63 0,-19-7 0,0 2 0,32 15 0,-34-13 0,-9-5 0,-1 0 0,0 1 0,0 1 0,10 8 0,-3-3 0,-14-11 0,0 1 0,0 1 0,0-1 0,-1 0 0,6 6 0,-8-8 0,0 0 0,0 0 0,0 0 0,0 0 0,0 0 0,0 1 0,1-1 0,-1 0 0,0 0 0,0 0 0,0 0 0,0 1 0,0-1 0,0 0 0,0 0 0,0 0 0,0 0 0,0 1 0,0-1 0,0 0 0,0 0 0,0 0 0,0 0 0,0 1 0,0-1 0,0 0 0,0 0 0,0 0 0,0 0 0,0 1 0,0-1 0,-1 0 0,1 0 0,0 0 0,0 0 0,0 1 0,0-1 0,0 0 0,0 0 0,0 0 0,-1 0 0,1 0 0,0 0 0,0 0 0,0 0 0,0 1 0,-1-1 0,1 0 0,0 0 0,0 0 0,-11 2 0,10-2 0,-133 1 0,71-3 0,-12 2 0,-102 11 0,-49 30 0,203-36 0,-33 9 0,49-11 0,0-1 0,0 1 0,0 0 0,1 1 0,-11 7 0,15-10 0,1 0 0,-1 1 0,0 0 0,1-1 0,-1 1 0,1 0 0,0 0 0,-2 1 0,3-2 0,0-1 0,0 1 0,0-1 0,-1 0 0,1 1 0,0-1 0,0 1 0,0-1 0,0 1 0,0-1 0,0 1 0,0-1 0,0 1 0,0-1 0,0 0 0,0 1 0,0-1 0,1 1 0,-1 0 0,0-1 0,1 1 0,-1-1 0,1 1 0,-1-1 0,1 1 0,-1-1 0,1 0 0,-1 1 0,1-1 0,-1 0 0,1 1 0,-1-1 0,1 0 0,-1 0 0,1 1 0,1-1 0,15 4 0,-10-3 0,-1 0 0,11 5 0,126 58 0,13 6 0,-94-46 0,259 105 0,-315-127 0,5 2 0,0 1 0,14 9 0,-24-14 0,-1 0 0,0 0 0,0 1 0,0-1 0,1 0 0,-1 0 0,0 0 0,0 0 0,0 0 0,0 0 0,1 0 0,-1 1 0,0-1 0,0 0 0,0 0 0,0 0 0,0 0 0,0 1 0,0-1 0,1 0 0,-1 0 0,0 0 0,0 0 0,0 1 0,0-1 0,0 0 0,0 0 0,0 0 0,0 1 0,-5 1 0,-13-1 0,15-1 0,-23 0 0,-4-1 0,-1 1 0,-49 8 0,30 3 0,-22 4 0,21-6 0,18-3 0,-46 3 0,73-8 0,1 0 0,-1 0 0,0 0 0,1 1 0,0 0 0,-1 1 0,1-1 0,-9 6 0,-4 2 0,0-1 0,8-5 0,1 0 0,0 1 0,-16 12 0,25-17-38,-1 0 0,1 0 0,0 0 1,-4 10-1177</inkml:trace>
+</inkml:ink>
+</file>
+
+<file path=ppt/ink/ink10.xml><?xml version="1.0" encoding="utf-8"?>
+<inkml:ink xmlns:inkml="http://www.w3.org/2003/InkML">
+  <inkml:definitions>
+    <inkml:context xml:id="ctx0">
+      <inkml:inkSource xml:id="inkSrc0">
+        <inkml:traceFormat>
+          <inkml:channel name="X" type="integer" min="-2.14748E9" max="2.14748E9" units="cm"/>
+          <inkml:channel name="Y" type="integer" min="-2.14748E9" max="2.14748E9" units="cm"/>
+          <inkml:channel name="F" type="integer" max="32767" units="dev"/>
+        </inkml:traceFormat>
+        <inkml:channelProperties>
+          <inkml:channelProperty channel="X" name="resolution" value="1000" units="1/cm"/>
+          <inkml:channelProperty channel="Y" name="resolution" value="1000" units="1/cm"/>
+          <inkml:channelProperty channel="F" name="resolution" value="0" units="1/dev"/>
+        </inkml:channelProperties>
+      </inkml:inkSource>
+      <inkml:timestamp xml:id="ts0" timeString="2026-03-28T04:06:08.290"/>
+    </inkml:context>
+    <inkml:brush xml:id="br0">
+      <inkml:brushProperty name="width" value="0.1" units="cm"/>
+      <inkml:brushProperty name="height" value="0.1" units="cm"/>
+    </inkml:brush>
+  </inkml:definitions>
+  <inkml:trace contextRef="#ctx0" brushRef="#br0">12 205 24575,'-9'257'0,"7"-249"0,1-18 0,1-26 0,8-56 0,14-37 0,-15 98 0,12-34 0,-15 54 0,0 0 0,1 0 0,0 1 0,1-1 0,0 2 0,11-15 0,-15 23 0,0-1 0,0 0 0,-1 0 0,1 1 0,0-1 0,0 1 0,0 0 0,0 0 0,1 0 0,-1 0 0,0 0 0,1 0 0,-1 0 0,0 1 0,1-1 0,-1 1 0,0-1 0,1 1 0,-1 0 0,1 0 0,-1 0 0,1 1 0,-1-1 0,1 1 0,-1-1 0,0 1 0,1 0 0,-1-1 0,3 3 0,0-1 0,0 1 0,-1 0 0,1 0 0,-1 0 0,1 1 0,-1-1 0,0 1 0,0 0 0,-1 0 0,1 1 0,5 8 0,-2 1 0,-1 0 0,0 0 0,-2 0 0,1 0 0,-2 1 0,1 0 0,0 15 0,1 106 0,-6-116 0,-4 34 0,2-41 0,3-13 0,0 0 0,0 0 0,0 0 0,0 0 0,0 0 0,-1 0 0,1 0 0,0 1 0,0-1 0,0 0 0,0 0 0,0 0 0,0 0 0,0 0 0,0 0 0,0 0 0,0 0 0,0 0 0,0 0 0,0 0 0,0 0 0,0 1 0,0-1 0,-1 0 0,1 0 0,0 0 0,0 0 0,0 0 0,0 0 0,0 0 0,0 0 0,0 0 0,0 0 0,0 0 0,0 0 0,-1 0 0,1 0 0,0 0 0,0 0 0,0 0 0,0 0 0,0 0 0,0 0 0,0 0 0,0 0 0,0 0 0,0 0 0,-1 0 0,1-1 0,0 1 0,0 0 0,0 0 0,0 0 0,0 0 0,0 0 0,0 0 0,0 0 0,0 0 0,0 0 0,0 0 0,0 0 0,0 0 0,0-1 0,-2-2 0,1 0 0,0-1 0,0 0 0,0 1 0,1-1 0,-1-6 0,0 1 0,0 3 0,-5-40 0,1 1 0,3-56 0,3 92 0,0 1 0,0-1 0,1 1 0,0-1 0,1 1 0,0 0 0,7-14 0,-8 18 0,0 0 0,0 1 0,1-1 0,-1 0 0,1 1 0,0 0 0,0-1 0,1 1 0,-1 1 0,1-1 0,-1 0 0,1 1 0,0 0 0,0-1 0,0 2 0,8-4 0,-10 5 0,0-1 0,0 1 0,1 0 0,-1-1 0,0 1 0,1 1 0,-1-1 0,0 0 0,0 0 0,1 1 0,-1-1 0,4 2 0,-3 0 0,1 0 0,0 0 0,-1 0 0,0 0 0,1 0 0,4 6 0,-1-1 0,0 1 0,-1 0 0,1 0 0,8 18 0,-7-10 0,-1 0 0,-1 0 0,0 0 0,3 22 0,-4-7-159,-2-1 0,-1 0 1,-3 42-1,0-53-571</inkml:trace>
+</inkml:ink>
+</file>
+
+<file path=ppt/ink/ink11.xml><?xml version="1.0" encoding="utf-8"?>
+<inkml:ink xmlns:inkml="http://www.w3.org/2003/InkML">
+  <inkml:definitions>
+    <inkml:context xml:id="ctx0">
+      <inkml:inkSource xml:id="inkSrc0">
+        <inkml:traceFormat>
+          <inkml:channel name="X" type="integer" min="-2.14748E9" max="2.14748E9" units="cm"/>
+          <inkml:channel name="Y" type="integer" min="-2.14748E9" max="2.14748E9" units="cm"/>
+          <inkml:channel name="F" type="integer" max="32767" units="dev"/>
+        </inkml:traceFormat>
+        <inkml:channelProperties>
+          <inkml:channelProperty channel="X" name="resolution" value="1000" units="1/cm"/>
+          <inkml:channelProperty channel="Y" name="resolution" value="1000" units="1/cm"/>
+          <inkml:channelProperty channel="F" name="resolution" value="0" units="1/dev"/>
+        </inkml:channelProperties>
+      </inkml:inkSource>
+      <inkml:timestamp xml:id="ts0" timeString="2026-03-28T04:13:50.294"/>
+    </inkml:context>
+    <inkml:brush xml:id="br0">
+      <inkml:brushProperty name="width" value="0.1" units="cm"/>
+      <inkml:brushProperty name="height" value="0.1" units="cm"/>
+    </inkml:brush>
+  </inkml:definitions>
+  <inkml:trace contextRef="#ctx0" brushRef="#br0">0 1 24575,'2'0'0</inkml:trace>
+</inkml:ink>
+</file>
+
+<file path=ppt/ink/ink2.xml><?xml version="1.0" encoding="utf-8"?>
+<inkml:ink xmlns:inkml="http://www.w3.org/2003/InkML">
+  <inkml:definitions>
+    <inkml:context xml:id="ctx0">
+      <inkml:inkSource xml:id="inkSrc0">
+        <inkml:traceFormat>
+          <inkml:channel name="X" type="integer" min="-2.14748E9" max="2.14748E9" units="cm"/>
+          <inkml:channel name="Y" type="integer" min="-2.14748E9" max="2.14748E9" units="cm"/>
+          <inkml:channel name="F" type="integer" max="32767" units="dev"/>
+        </inkml:traceFormat>
+        <inkml:channelProperties>
+          <inkml:channelProperty channel="X" name="resolution" value="1000" units="1/cm"/>
+          <inkml:channelProperty channel="Y" name="resolution" value="1000" units="1/cm"/>
+          <inkml:channelProperty channel="F" name="resolution" value="0" units="1/dev"/>
+        </inkml:channelProperties>
+      </inkml:inkSource>
+      <inkml:timestamp xml:id="ts0" timeString="2026-03-28T04:05:41.277"/>
+    </inkml:context>
+    <inkml:brush xml:id="br0">
+      <inkml:brushProperty name="width" value="0.35" units="cm"/>
+      <inkml:brushProperty name="height" value="0.35" units="cm"/>
+      <inkml:brushProperty name="color" value="#E71224"/>
+    </inkml:brush>
+  </inkml:definitions>
+  <inkml:trace contextRef="#ctx0" brushRef="#br0">231 0 24575,'21'1'-858,"0"0"0,0 2 0,22 5-1,59 21-2328,-100-28 3342,0-1 0,0 1-1,0 0 1,-1 0 0,1 0 0,0 0 0,0 0-1,-1 0 1,1 0 0,1 2 0,-2-2-84,-1 0 0,1-1 0,-1 1 1,0 0-1,1-1 0,-1 1 0,0 0 0,0 0 1,1-1-1,-1 1 0,0 0 0,0 0 1,0-1-1,0 1 0,0 0 0,0 0 1,0-1-1,0 1 0,0 0 0,0 0 0,-1-1 1,1 1-1,0 0 0,0 0 0,-1-1 1,1 1-1,0 0 0,-2 0 0,-2 5 265,0-1-1,-1 1 1,0-1 0,0-1-1,-1 1 1,-7 5-1,-7 6 168,-43 30-503,27-15 0,10-7 0,-42 27 0,62-47 0,-1 1 0,0-1 0,1 0 0,-1 0 0,-1-1 0,1 0 0,-13 4 0,13-5 0,0 0 0,0 1 0,1-1 0,-1 1 0,0 1 0,1-1 0,-11 9 0,16-12 0,1 1 0,-1-1 0,1 0 0,-1 1 0,1-1 0,-1 1 0,1-1 0,0 1 0,-1-1 0,1 1 0,0-1 0,-1 1 0,1-1 0,-1 2 0,1-2 0,0 0 0,0 0 0,0 1 0,0-1 0,0 0 0,1 0 0,-1 0 0,0 1 0,0-1 0,0 0 0,0 0 0,0 0 0,0 1 0,0-1 0,0 0 0,1 0 0,-1 0 0,0 0 0,0 0 0,0 1 0,0-1 0,0 0 0,1 0 0,-1 0 0,0 0 0,0 0 0,0 0 0,1 0 0,2 1 0,0 0 0,0 0 0,0-1 0,5 1 0,-6-1 0,83 13 0,-29-3 0,252 47 0,-301-56 0,-4 0 0,0-1 0,0 1 0,0-1 0,0 1 0,-1 0 0,1 0 0,0 0 0,-1 1 0,1-1 0,-1 1 0,3 1 0,-5-3 0,1 0 0,-1 1 0,0-1 0,0 0 0,0 0 0,0 0 0,1 1 0,-1-1 0,0 0 0,0 0 0,0 1 0,0-1 0,0 0 0,0 0 0,0 1 0,0-1 0,0 0 0,0 1 0,0-1 0,0 0 0,0 0 0,0 1 0,0-1 0,0 0 0,0 0 0,0 1 0,0-1 0,0 0 0,0 0 0,0 1 0,0-1 0,-1 0 0,1 0 0,0 0 0,0 1 0,0-1 0,0 0 0,-1 0 0,1 1 0,-11 5 0,1-2 0,0-1 0,-1 0 0,-16 2 0,-2 0 0,-29 9 0,-58 22 0,92-26 0,-43 24 0,-17 18 0,79-48 0,-9 5 0,-22 19 0,35-28-3,1 0 0,0 1 0,0-1 0,-1 0 0,1 0 1,0 1-1,0-1 0,-1 0 0,1 1 0,0-1 0,0 0 0,0 1 0,-1-1 0,1 0 0,0 1 0,0 0 0,0-1-2,0 0-1,0 0 1,0 0 0,0 1-1,0-1 1,0 0-1,1 0 1,-1 0 0,0 0-1,0 0 1,0 0-1,0 1 1,0-1 0,0 0-1,0 0 1,1 0 0,-1 0-1,0 0 1,0 0-1,0 0 1,0 0 0,0 0-1,1 0 1,-1 0 0,0 0-1,0 0 1,0 0-1,16 0-596,-13 0 422,374-10-5621,-358 11 6293,27 3-1,-45-4-381,15 11 1853,-16-11-1932,-3 4 430,2-3-384,1-1 0,-1 1 0,0-1-1,-1 1 1,-15 7 476,0 0-1,-1-2 1,0 0-1,-26 5 1,27-7-464,-10 3-89,-126 32 0,4 9 0,135-43 0,-24 14 0,35-18 0,0 1 0,0 0 0,1 0 0,-1 0 0,0 1 0,1-1 0,-1 1 0,1-1 0,0 1 0,-1 0 0,2 0 0,-1 0 0,-2 4 0,3-6 0,1 0 0,0-1 0,0 1 0,0 0 0,0-1 0,-1 1 0,1 0 0,0-1 0,0 1 0,0 0 0,0-1 0,0 1 0,1 0 0,-1-1 0,0 1 0,0 0 0,0-1 0,0 1 0,1 0 0,-1-1 0,0 1 0,1-1 0,-1 1 0,0-1 0,1 1 0,-1 0 0,1-1 0,-1 0 0,1 1 0,-1-1 0,1 1 0,0 0 0,2 0 0,1 1 0,-1-1 0,0 0 0,0 0 0,5 1 0,-1 0 0,24 5 0,1-1 0,65 3 0,-75-8 0,80 3 0,25 1 0,-123-4 0,10 1 0,-14-2 0,1 0 0,-1 0 0,1 0 0,-1 0 0,1 0 0,-1 1 0,1-1 0,-1 0 0,0 0 0,1 1 0,-1-1 0,1 0 0,-1 1 0,0-1 0,1 0 0,-1 1 0,0-1 0,0 0 0,1 1 0,-1-1 0,1 1 0,-1 0 0,0-1 0,0 0 0,0 1 0,0-1 0,0 0 0,0 1 0,0-1 0,0 0 0,-1 1 0,1-1 0,0 0 0,0 1 0,0-1 0,0 0 0,0 1 0,0-1 0,-1 0 0,1 0 0,0 1 0,0-1 0,0 0 0,-1 0 0,1 1 0,0-1 0,0 0 0,-1 0 0,1 0 0,0 1 0,-1-1 0,-10 5 0,-3-2 0,-1 0 0,0-1 0,0 0 0,0-1 0,-18-1 0,12 0 0,-12 0 0,9-1 0,-1 2 0,1 1 0,-39 7 0,61-9 0,-11 5 0,13-5 0,0 0 0,0 0 0,-1 0 0,1 0 0,0 0 0,0 0 0,0 0 0,0 0 0,-1 0 0,1 0 0,0 0 0,0 0 0,0 1 0,0-1 0,0 0 0,0 0 0,0 0 0,-1 0 0,1 0 0,0 0 0,0 1 0,0-1 0,0 0 0,0 0 0,0 0 0,0 0 0,0 0 0,0 1 0,0-1 0,0 0 0,0 0 0,0 0 0,0 0 0,0 0 0,0 1 0,0-1 0,0 0 0,0 0 0,0 0 0,0 0 0,0 1 0,0-1 0,0 0 0,0 0 0,0 0 0,0 0 0,0 0 0,0 1 0,1-1 0,-1 0 0,0 0 0,0 0 0,0 0 0,0 0 0,0 0 0,0 0 0,1 0 0,-1 1 0,0-1 0,0 0 0,0 0 0,0 0 0,0 0 0,1 0 0,-1 0 0,10 4 0,1 1 0,0-2 0,0 0 0,0 0 0,13 1 0,-7-1 0,154 26-1365</inkml:trace>
+</inkml:ink>
+</file>
+
+<file path=ppt/ink/ink3.xml><?xml version="1.0" encoding="utf-8"?>
+<inkml:ink xmlns:inkml="http://www.w3.org/2003/InkML">
+  <inkml:definitions>
+    <inkml:context xml:id="ctx0">
+      <inkml:inkSource xml:id="inkSrc0">
+        <inkml:traceFormat>
+          <inkml:channel name="X" type="integer" min="-2.14748E9" max="2.14748E9" units="cm"/>
+          <inkml:channel name="Y" type="integer" min="-2.14748E9" max="2.14748E9" units="cm"/>
+          <inkml:channel name="F" type="integer" max="32767" units="dev"/>
+        </inkml:traceFormat>
+        <inkml:channelProperties>
+          <inkml:channelProperty channel="X" name="resolution" value="1000" units="1/cm"/>
+          <inkml:channelProperty channel="Y" name="resolution" value="1000" units="1/cm"/>
+          <inkml:channelProperty channel="F" name="resolution" value="0" units="1/dev"/>
+        </inkml:channelProperties>
+      </inkml:inkSource>
+      <inkml:timestamp xml:id="ts0" timeString="2026-03-28T04:06:00.440"/>
+    </inkml:context>
+    <inkml:brush xml:id="br0">
+      <inkml:brushProperty name="width" value="0.1" units="cm"/>
+      <inkml:brushProperty name="height" value="0.1" units="cm"/>
+    </inkml:brush>
+  </inkml:definitions>
+  <inkml:trace contextRef="#ctx0" brushRef="#br0">0 313 24575,'0'-5'0,"1"0"0,-1 1 0,1-1 0,0 1 0,0-1 0,4-8 0,14-25 0,-6 13 0,60-110 0,-72 133 0,13-27 0,-11 20 0,9-13 0,-12 21 0,1 0 0,-1 1 0,0-1 0,1 0 0,-1 1 0,1-1 0,-1 0 0,1 1 0,0-1 0,-1 1 0,1-1 0,0 1 0,-1-1 0,1 1 0,0 0 0,-1-1 0,1 1 0,0 0 0,0-1 0,0 1 0,0 0 0,0 0 0,-1 1 0,1-1 0,0 0 0,-1 0 0,1 1 0,0-1 0,-1 1 0,1-1 0,-1 1 0,1-1 0,-1 0 0,1 1 0,-1 0 0,1-1 0,-1 1 0,0-1 0,1 1 0,-1 0 0,0-1 0,1 1 0,-1-1 0,0 1 0,1 1 0,3 12 0,0 0 0,-1 0 0,3 28 0,-1-5 0,9 48 0,5 153 0,-21 41-1365</inkml:trace>
+</inkml:ink>
+</file>
+
+<file path=ppt/ink/ink4.xml><?xml version="1.0" encoding="utf-8"?>
+<inkml:ink xmlns:inkml="http://www.w3.org/2003/InkML">
+  <inkml:definitions>
+    <inkml:context xml:id="ctx0">
+      <inkml:inkSource xml:id="inkSrc0">
+        <inkml:traceFormat>
+          <inkml:channel name="X" type="integer" min="-2.14748E9" max="2.14748E9" units="cm"/>
+          <inkml:channel name="Y" type="integer" min="-2.14748E9" max="2.14748E9" units="cm"/>
+          <inkml:channel name="F" type="integer" max="32767" units="dev"/>
+        </inkml:traceFormat>
+        <inkml:channelProperties>
+          <inkml:channelProperty channel="X" name="resolution" value="1000" units="1/cm"/>
+          <inkml:channelProperty channel="Y" name="resolution" value="1000" units="1/cm"/>
+          <inkml:channelProperty channel="F" name="resolution" value="0" units="1/dev"/>
+        </inkml:channelProperties>
+      </inkml:inkSource>
+      <inkml:timestamp xml:id="ts0" timeString="2026-03-28T04:06:01.451"/>
+    </inkml:context>
+    <inkml:brush xml:id="br0">
+      <inkml:brushProperty name="width" value="0.1" units="cm"/>
+      <inkml:brushProperty name="height" value="0.1" units="cm"/>
+    </inkml:brush>
+  </inkml:definitions>
+  <inkml:trace contextRef="#ctx0" brushRef="#br0">0 179 24575,'1'17'0,"0"-1"0,8 31 0,-3-17 0,0 2 0,13 39 0,-14-57 0,0-1 0,1 0 0,0 1 0,1-2 0,12 17 0,-10-16 0,-2-3 0,1-1 0,16 17 0,-21-23 0,0 0 0,0-1 0,1 0 0,-1 0 0,1 0 0,-1 0 0,1 0 0,0-1 0,0 0 0,0 1 0,0-1 0,7 0 0,1 0 0,0 0 0,0-1 0,0-1 0,0 0 0,1 0 0,-1-2 0,-1 1 0,1-1 0,0-1 0,-1 0 0,1-1 0,-1 0 0,14-9 0,-19 9 0,0 1 0,-1-1 0,1-1 0,-1 1 0,0-1 0,0 1 0,-1-1 0,0-1 0,0 1 0,0 0 0,-1-1 0,0 0 0,0 0 0,-1 0 0,0 0 0,2-8 0,-2 0 0,0-1 0,0 0 0,-2 0 0,0 0 0,0 0 0,-5-23 0,3 29 0,-1-1 0,0 0 0,-1 0 0,0 1 0,-9-17 0,-33-46 0,17 30 0,22 31 0,0 1 0,-1 1 0,-13-15 0,18 22 0,0 0 0,0 1 0,-1-1 0,1 1 0,0 0 0,-1 0 0,0 0 0,1 0 0,-1 1 0,0-1 0,0 1 0,0 0 0,0 0 0,0 1 0,-6-1 0,-9 0 0,1 2 0,-1 0 0,0 1 0,-36 9 0,35-3-1365,3 0-5461</inkml:trace>
+</inkml:ink>
+</file>
+
+<file path=ppt/ink/ink5.xml><?xml version="1.0" encoding="utf-8"?>
+<inkml:ink xmlns:inkml="http://www.w3.org/2003/InkML">
+  <inkml:definitions>
+    <inkml:context xml:id="ctx0">
+      <inkml:inkSource xml:id="inkSrc0">
+        <inkml:traceFormat>
+          <inkml:channel name="X" type="integer" min="-2.14748E9" max="2.14748E9" units="cm"/>
+          <inkml:channel name="Y" type="integer" min="-2.14748E9" max="2.14748E9" units="cm"/>
+          <inkml:channel name="F" type="integer" max="32767" units="dev"/>
+        </inkml:traceFormat>
+        <inkml:channelProperties>
+          <inkml:channelProperty channel="X" name="resolution" value="1000" units="1/cm"/>
+          <inkml:channelProperty channel="Y" name="resolution" value="1000" units="1/cm"/>
+          <inkml:channelProperty channel="F" name="resolution" value="0" units="1/dev"/>
+        </inkml:channelProperties>
+      </inkml:inkSource>
+      <inkml:timestamp xml:id="ts0" timeString="2026-03-28T04:06:02.355"/>
+    </inkml:context>
+    <inkml:brush xml:id="br0">
+      <inkml:brushProperty name="width" value="0.1" units="cm"/>
+      <inkml:brushProperty name="height" value="0.1" units="cm"/>
+    </inkml:brush>
+  </inkml:definitions>
+  <inkml:trace contextRef="#ctx0" brushRef="#br0">1 0 24575,'-1'109'0,"2"116"0,15-2 0,-13-193 0,12 62 0,-10-77 0,-5-15 0,0 0 0,0 0 0,0 0 0,0 0 0,0 0 0,0 0 0,0 0 0,0 0 0,0 0 0,1 0 0,-1 0 0,0 0 0,0 0 0,0 0 0,0 0 0,0 0 0,0 0 0,0 0 0,0 0 0,0 0 0,1 0 0,-1 0 0,0 0 0,0 0 0,0 0 0,0 0 0,0 0 0,0 0 0,0 0 0,0 0 0,1 0 0,-1 0 0,0 0 0,0 0 0,0 0 0,0 0 0,0 0 0,0 0 0,0 0 0,0 0 0,0 0 0,0 0 0,0 0 0,0-1 0,1 1 0,-1 0 0,0 0 0,0 0 0,0 0 0,0 0 0,0 0 0,0 0 0,0 0 0,0 0 0,0-1 0,0 1 0,0 0 0,0 0 0,0 0 0,0 0 0,0 0 0,0 0 0,0 0 0,0 0 0,0 0 0,0-1 0,1-6 0,1 0 0,-1 0 0,-1-1 0,0-12 0,1-6 0,1 1 0,7-31 0,-7 46 0,1 0 0,0 0 0,1 0 0,0 0 0,9-16 0,-5 14 0,-1 1 0,2 0 0,-1 0 0,2 1 0,18-17 0,-23 24 0,-1 0 0,0 0 0,1 0 0,0 0 0,-1 1 0,1 0 0,0 0 0,0 0 0,1 0 0,-1 1 0,0 0 0,0 0 0,1 1 0,-1-1 0,0 1 0,1 0 0,-1 1 0,7 0 0,-10 0 0,1 0 0,0 0 0,-1 0 0,1 0 0,-1 0 0,0 1 0,1-1 0,-1 1 0,0 0 0,0-1 0,0 1 0,0 0 0,0 0 0,3 5 0,1 2 0,0 1 0,6 13 0,-9-16 0,6 12 0,-1 0 0,10 40 0,4 43 0,-19-72 0,-2-22 0,0 0 0,0 0 0,3 12 0,1-14-1365</inkml:trace>
+</inkml:ink>
+</file>
+
+<file path=ppt/ink/ink6.xml><?xml version="1.0" encoding="utf-8"?>
+<inkml:ink xmlns:inkml="http://www.w3.org/2003/InkML">
+  <inkml:definitions>
+    <inkml:context xml:id="ctx0">
+      <inkml:inkSource xml:id="inkSrc0">
+        <inkml:traceFormat>
+          <inkml:channel name="X" type="integer" min="-2.14748E9" max="2.14748E9" units="cm"/>
+          <inkml:channel name="Y" type="integer" min="-2.14748E9" max="2.14748E9" units="cm"/>
+          <inkml:channel name="F" type="integer" max="32767" units="dev"/>
+        </inkml:traceFormat>
+        <inkml:channelProperties>
+          <inkml:channelProperty channel="X" name="resolution" value="1000" units="1/cm"/>
+          <inkml:channelProperty channel="Y" name="resolution" value="1000" units="1/cm"/>
+          <inkml:channelProperty channel="F" name="resolution" value="0" units="1/dev"/>
+        </inkml:channelProperties>
+      </inkml:inkSource>
+      <inkml:timestamp xml:id="ts0" timeString="2026-03-28T04:06:03.405"/>
+    </inkml:context>
+    <inkml:brush xml:id="br0">
+      <inkml:brushProperty name="width" value="0.1" units="cm"/>
+      <inkml:brushProperty name="height" value="0.1" units="cm"/>
+    </inkml:brush>
+  </inkml:definitions>
+  <inkml:trace contextRef="#ctx0" brushRef="#br0">1 142 24575,'0'323'0,"0"-732"0,0 405 0,0-1 0,0 1 0,1-1 0,-1 1 0,1-1 0,1-4 0,-1 8 0,-1 0 0,1 0 0,-1 0 0,1 0 0,0 0 0,-1 0 0,1 0 0,0 0 0,0 0 0,0 0 0,0 0 0,0 0 0,0 0 0,0 1 0,0-1 0,0 0 0,0 1 0,0-1 0,0 1 0,1-1 0,-1 1 0,0 0 0,0-1 0,0 1 0,1 0 0,1 0 0,0 0 0,0 0 0,1 0 0,-1 1 0,1-1 0,-1 1 0,0 0 0,0 0 0,1 0 0,-1 0 0,6 4 0,2 2 0,16 12 0,-25-18 0,18 15 0,-1 1 0,0 1 0,-1 0 0,17 24 0,-24-26 0,0 0 0,0 0 0,-2 1 0,0 0 0,-1 1 0,6 21 0,-10-25 0,-2 0 0,1 0 0,-2 0 0,0 0 0,-2 26 0,1-38 0,0-4 0,-1-7 0,0-17 0,3-9 0,1-1 0,1 1 0,3 0 0,0 0 0,18-47 0,-22 73 0,1 1 0,0 0 0,0 0 0,1 0 0,0 1 0,9-11 0,-11 15 0,0-1 0,1 1 0,-1-1 0,1 1 0,0 0 0,0 1 0,0-1 0,1 1 0,-1-1 0,1 1 0,-1 0 0,1 1 0,6-2 0,-8 3 0,-1-1 0,1 1 0,0 1 0,0-1 0,0 0 0,-1 1 0,1-1 0,0 1 0,0 0 0,-1 0 0,1 0 0,-1 0 0,1 0 0,-1 1 0,3 1 0,1 1 0,-1 0 0,0 0 0,0 1 0,0 0 0,5 6 0,5 10 0,-1 1 0,0 0 0,-2 0 0,-1 1 0,-1 1 0,10 30 0,-9-15 0,-2 0 0,-2 0 0,4 53 0,-10-76 0,-1-16-24,0 0-1,0 0 1,0 1 0,0-1-1,0 0 1,0 0 0,0 0-1,0 0 1,0 0-1,1 0 1,-1 0 0,0 0-1,0 0 1,0 0 0,0 0-1,0 1 1,0-1-1,0 0 1,0 0 0,0 0-1,0 0 1,0 0 0,0 0-1,0 0 1,-1 0-1,1 0 1,0 0 0,0 0-1,0 1 1,0-1-1,0 0 1,0 0 0,0 0-1,0 0 1,0 0 0,0 0-1,0 0 1,0 0-1,0 0 1,0 0 0,0 0-1,0 0 1,0 0 0,-1 0-1,1 0 1,0 0-1,0 0 1,0 0 0,0 0-1,0 0 1,0 0-1,0 0 1,0 0 0,0 0-1,-1 0 1</inkml:trace>
+</inkml:ink>
+</file>
+
+<file path=ppt/ink/ink7.xml><?xml version="1.0" encoding="utf-8"?>
+<inkml:ink xmlns:inkml="http://www.w3.org/2003/InkML">
+  <inkml:definitions>
+    <inkml:context xml:id="ctx0">
+      <inkml:inkSource xml:id="inkSrc0">
+        <inkml:traceFormat>
+          <inkml:channel name="X" type="integer" min="-2.14748E9" max="2.14748E9" units="cm"/>
+          <inkml:channel name="Y" type="integer" min="-2.14748E9" max="2.14748E9" units="cm"/>
+          <inkml:channel name="F" type="integer" max="32767" units="dev"/>
+        </inkml:traceFormat>
+        <inkml:channelProperties>
+          <inkml:channelProperty channel="X" name="resolution" value="1000" units="1/cm"/>
+          <inkml:channelProperty channel="Y" name="resolution" value="1000" units="1/cm"/>
+          <inkml:channelProperty channel="F" name="resolution" value="0" units="1/dev"/>
+        </inkml:channelProperties>
+      </inkml:inkSource>
+      <inkml:timestamp xml:id="ts0" timeString="2026-03-28T04:06:05.066"/>
+    </inkml:context>
+    <inkml:brush xml:id="br0">
+      <inkml:brushProperty name="width" value="0.1" units="cm"/>
+      <inkml:brushProperty name="height" value="0.1" units="cm"/>
+    </inkml:brush>
+  </inkml:definitions>
+  <inkml:trace contextRef="#ctx0" brushRef="#br0">13 486 24575,'0'-1'0,"-1"1"0,1 0 0,-1-1 0,1 1 0,-1 0 0,1-1 0,0 1 0,-1-1 0,1 1 0,0-1 0,-1 1 0,1-1 0,0 1 0,-1-1 0,1 1 0,0-1 0,0 1 0,0-1 0,0 0 0,-1 1 0,1-1 0,0 1 0,0-2 0,0 1 0,-2-9 0,1 0 0,-1-1 0,2 1 0,0 0 0,0 0 0,1-1 0,0 1 0,0 0 0,2 0 0,-1 0 0,1 0 0,0 0 0,9-17 0,89-136 0,-50 84 0,-43 67 0,-3 3 0,0 1 0,1-1 0,0 1 0,10-10 0,-15 17 0,-1 1 0,1-1 0,0 1 0,0-1 0,-1 1 0,1-1 0,0 1 0,0-1 0,0 1 0,0 0 0,-1-1 0,1 1 0,0 0 0,0 0 0,0-1 0,1 1 0,-1 0 0,-1 0 0,1 1 0,-1-1 0,1 0 0,0 0 0,-1 0 0,1 1 0,-1-1 0,1 0 0,-1 1 0,1-1 0,-1 0 0,1 1 0,-1-1 0,1 1 0,-1-1 0,0 1 0,1 0 0,1 2 0,-1 0 0,1 1 0,-1-1 0,0 0 0,0 1 0,0-1 0,0 5 0,3 26 0,-2-1 0,-3 45 0,0-42 0,-7 143 0,0 64 0,8-225-1365,0-1-5461</inkml:trace>
+</inkml:ink>
+</file>
+
+<file path=ppt/ink/ink8.xml><?xml version="1.0" encoding="utf-8"?>
+<inkml:ink xmlns:inkml="http://www.w3.org/2003/InkML">
+  <inkml:definitions>
+    <inkml:context xml:id="ctx0">
+      <inkml:inkSource xml:id="inkSrc0">
+        <inkml:traceFormat>
+          <inkml:channel name="X" type="integer" min="-2.14748E9" max="2.14748E9" units="cm"/>
+          <inkml:channel name="Y" type="integer" min="-2.14748E9" max="2.14748E9" units="cm"/>
+          <inkml:channel name="F" type="integer" max="32767" units="dev"/>
+        </inkml:traceFormat>
+        <inkml:channelProperties>
+          <inkml:channelProperty channel="X" name="resolution" value="1000" units="1/cm"/>
+          <inkml:channelProperty channel="Y" name="resolution" value="1000" units="1/cm"/>
+          <inkml:channelProperty channel="F" name="resolution" value="0" units="1/dev"/>
+        </inkml:channelProperties>
+      </inkml:inkSource>
+      <inkml:timestamp xml:id="ts0" timeString="2026-03-28T04:06:05.936"/>
+    </inkml:context>
+    <inkml:brush xml:id="br0">
+      <inkml:brushProperty name="width" value="0.1" units="cm"/>
+      <inkml:brushProperty name="height" value="0.1" units="cm"/>
+    </inkml:brush>
+  </inkml:definitions>
+  <inkml:trace contextRef="#ctx0" brushRef="#br0">49 564 24575,'-1'3'0,"-1"-1"0,1 0 0,-1 0 0,0 1 0,-2 1 0,-7 9 0,7-6 0,0 1 0,1 1 0,0-1 0,0 0 0,1 1 0,0-1 0,0 1 0,1 0 0,0-1 0,1 1 0,0 0 0,0 0 0,1 0 0,0-1 0,4 16 0,-4-21 0,0 0 0,0 1 0,0-1 0,1-1 0,0 1 0,-1 0 0,1 0 0,0 0 0,0-1 0,1 1 0,-1-1 0,0 0 0,1 0 0,-1 0 0,1 0 0,0 0 0,0 0 0,0-1 0,4 3 0,1-2 0,0 0 0,0 0 0,0 0 0,0-1 0,0-1 0,16 0 0,-1 0 0,0-1 0,0-1 0,33-8 0,-43 6 0,0 1 0,-1-2 0,0 0 0,1 0 0,-2-1 0,1-1 0,16-12 0,-14 8 0,-1 0 0,-1 0 0,0-2 0,-1 1 0,0-2 0,-1 1 0,0-1 0,-1-1 0,-1 0 0,0 0 0,-1-1 0,-1 0 0,0 0 0,-1 0 0,-1-1 0,0 1 0,1-34 0,-3 17 0,-3 0 0,0 1 0,-2-1 0,-2 1 0,0 0 0,-3 0 0,-12-35 0,14 52 0,0-1 0,-1 1 0,-13-18 0,16 26 0,-1 0 0,0 0 0,-1 0 0,1 1 0,-1 0 0,0 1 0,-1-1 0,-9-5 0,13 9 0,1 1 0,-1-1 0,0 1 0,1 0 0,-1 0 0,0 1 0,0-1 0,0 1 0,0-1 0,0 1 0,0 0 0,-5 0 0,4 1 0,0 0 0,-1 0 0,1 0 0,0 0 0,0 1 0,0-1 0,-7 5 0,0 1 0,1 0 0,1 1 0,-1 0 0,1 1 0,-9 10 0,-7 13 0,-41 68 0,65-99 0,-7 13-273,0 0 0,1 0 0,0 1 0,-4 16 0</inkml:trace>
+</inkml:ink>
+</file>
+
+<file path=ppt/ink/ink9.xml><?xml version="1.0" encoding="utf-8"?>
+<inkml:ink xmlns:inkml="http://www.w3.org/2003/InkML">
+  <inkml:definitions>
+    <inkml:context xml:id="ctx0">
+      <inkml:inkSource xml:id="inkSrc0">
+        <inkml:traceFormat>
+          <inkml:channel name="X" type="integer" min="-2.14748E9" max="2.14748E9" units="cm"/>
+          <inkml:channel name="Y" type="integer" min="-2.14748E9" max="2.14748E9" units="cm"/>
+          <inkml:channel name="F" type="integer" max="32767" units="dev"/>
+        </inkml:traceFormat>
+        <inkml:channelProperties>
+          <inkml:channelProperty channel="X" name="resolution" value="1000" units="1/cm"/>
+          <inkml:channelProperty channel="Y" name="resolution" value="1000" units="1/cm"/>
+          <inkml:channelProperty channel="F" name="resolution" value="0" units="1/dev"/>
+        </inkml:channelProperties>
+      </inkml:inkSource>
+      <inkml:timestamp xml:id="ts0" timeString="2026-03-28T04:06:06.890"/>
+    </inkml:context>
+    <inkml:brush xml:id="br0">
+      <inkml:brushProperty name="width" value="0.1" units="cm"/>
+      <inkml:brushProperty name="height" value="0.1" units="cm"/>
+    </inkml:brush>
+  </inkml:definitions>
+  <inkml:trace contextRef="#ctx0" brushRef="#br0">1 1 24575,'0'851'0,"0"-860"0,5-18 0,-1-2 0,3-40 0,27-165 0,-30 216 0,2 0 0,8-20 0,-13 36 0,-1 0 0,1 1 0,1-1 0,-1 0 0,0 1 0,0-1 0,1 1 0,-1-1 0,0 1 0,1-1 0,0 1 0,-1 0 0,1 0 0,0 0 0,-1 0 0,1 0 0,0 0 0,0 0 0,0 1 0,0-1 0,0 1 0,0-1 0,0 1 0,0 0 0,0 0 0,0 0 0,0 0 0,0 0 0,0 0 0,0 1 0,3 0 0,-1 0 0,0 0 0,0 0 0,-1 1 0,1-1 0,-1 1 0,1 0 0,-1 0 0,1 0 0,-1 0 0,0 0 0,0 1 0,0 0 0,-1-1 0,1 1 0,4 6 0,0 5 57,-1-1 0,0 1 0,0 0 0,-2 1 0,6 28 0,-5-12-911,1 57 1,-6-67-5973</inkml:trace>
+</inkml:ink>
 </file>
 
 <file path=ppt/notesMasters/notesMaster1.xml><?xml version="1.0" encoding="utf-8"?>
@@ -1221,6 +1035,90 @@
           <a:p>
             <a:fld id="{884FB04C-44F8-4F5F-80E8-63EAE06CAE5F}" type="slidenum">
               <a:rPr lang="en-US" smtClean="0"/>
+              <a:t>4</a:t>
+            </a:fld>
+            <a:endParaRPr lang="en-US"/>
+          </a:p>
+        </p:txBody>
+      </p:sp>
+    </p:spTree>
+    <p:extLst>
+      <p:ext uri="{BB962C8B-B14F-4D97-AF65-F5344CB8AC3E}">
+        <p14:creationId xmlns:p14="http://schemas.microsoft.com/office/powerpoint/2010/main" val="1717814195"/>
+      </p:ext>
+    </p:extLst>
+  </p:cSld>
+  <p:clrMapOvr>
+    <a:masterClrMapping/>
+  </p:clrMapOvr>
+</p:notes>
+</file>
+
+<file path=ppt/notesSlides/notesSlide2.xml><?xml version="1.0" encoding="utf-8"?>
+<p:notes xmlns:a="http://schemas.openxmlformats.org/drawingml/2006/main" xmlns:r="http://schemas.openxmlformats.org/officeDocument/2006/relationships" xmlns:p="http://schemas.openxmlformats.org/presentationml/2006/main">
+  <p:cSld>
+    <p:spTree>
+      <p:nvGrpSpPr>
+        <p:cNvPr id="1" name=""/>
+        <p:cNvGrpSpPr/>
+        <p:nvPr/>
+      </p:nvGrpSpPr>
+      <p:grpSpPr>
+        <a:xfrm>
+          <a:off x="0" y="0"/>
+          <a:ext cx="0" cy="0"/>
+          <a:chOff x="0" y="0"/>
+          <a:chExt cx="0" cy="0"/>
+        </a:xfrm>
+      </p:grpSpPr>
+      <p:sp>
+        <p:nvSpPr>
+          <p:cNvPr id="2" name="Slide Image Placeholder 1"/>
+          <p:cNvSpPr>
+            <a:spLocks noGrp="1" noRot="1" noChangeAspect="1"/>
+          </p:cNvSpPr>
+          <p:nvPr>
+            <p:ph type="sldImg"/>
+          </p:nvPr>
+        </p:nvSpPr>
+        <p:spPr/>
+      </p:sp>
+      <p:sp>
+        <p:nvSpPr>
+          <p:cNvPr id="3" name="Notes Placeholder 2"/>
+          <p:cNvSpPr>
+            <a:spLocks noGrp="1"/>
+          </p:cNvSpPr>
+          <p:nvPr>
+            <p:ph type="body" idx="1"/>
+          </p:nvPr>
+        </p:nvSpPr>
+        <p:spPr/>
+        <p:txBody>
+          <a:bodyPr/>
+          <a:lstStyle/>
+          <a:p>
+            <a:endParaRPr lang="en-US" dirty="0"/>
+          </a:p>
+        </p:txBody>
+      </p:sp>
+      <p:sp>
+        <p:nvSpPr>
+          <p:cNvPr id="4" name="Slide Number Placeholder 3"/>
+          <p:cNvSpPr>
+            <a:spLocks noGrp="1"/>
+          </p:cNvSpPr>
+          <p:nvPr>
+            <p:ph type="sldNum" sz="quarter" idx="5"/>
+          </p:nvPr>
+        </p:nvSpPr>
+        <p:spPr/>
+        <p:txBody>
+          <a:bodyPr/>
+          <a:lstStyle/>
+          <a:p>
+            <a:fld id="{884FB04C-44F8-4F5F-80E8-63EAE06CAE5F}" type="slidenum">
+              <a:rPr lang="en-US" smtClean="0"/>
               <a:t>5</a:t>
             </a:fld>
             <a:endParaRPr lang="en-US"/>
@@ -1240,7 +1138,7 @@
 </p:notes>
 </file>
 
-<file path=ppt/notesSlides/notesSlide2.xml><?xml version="1.0" encoding="utf-8"?>
+<file path=ppt/notesSlides/notesSlide3.xml><?xml version="1.0" encoding="utf-8"?>
 <p:notes xmlns:a="http://schemas.openxmlformats.org/drawingml/2006/main" xmlns:r="http://schemas.openxmlformats.org/officeDocument/2006/relationships" xmlns:p="http://schemas.openxmlformats.org/presentationml/2006/main">
   <p:cSld>
     <p:spTree>
@@ -5112,8 +5010,8 @@
         </p:blipFill>
         <p:spPr>
           <a:xfrm>
-            <a:off x="0" y="1840890"/>
-            <a:ext cx="8764172" cy="3176220"/>
+            <a:off x="-7343016" y="1396902"/>
+            <a:ext cx="11822929" cy="4284743"/>
           </a:xfrm>
           <a:prstGeom prst="rect">
             <a:avLst/>
@@ -5142,14 +5040,617 @@
         </p:blipFill>
         <p:spPr>
           <a:xfrm>
-            <a:off x="8764172" y="1840890"/>
-            <a:ext cx="3452913" cy="3176220"/>
+            <a:off x="4765497" y="42204"/>
+            <a:ext cx="6685909" cy="6150146"/>
           </a:xfrm>
           <a:prstGeom prst="rect">
             <a:avLst/>
           </a:prstGeom>
         </p:spPr>
       </p:pic>
+      <mc:AlternateContent xmlns:mc="http://schemas.openxmlformats.org/markup-compatibility/2006">
+        <mc:Choice xmlns:p14="http://schemas.microsoft.com/office/powerpoint/2010/main" Requires="p14">
+          <p:contentPart p14:bwMode="auto" r:id="rId4">
+            <p14:nvContentPartPr>
+              <p14:cNvPr id="7" name="Ink 6">
+                <a:extLst>
+                  <a:ext uri="{FF2B5EF4-FFF2-40B4-BE49-F238E27FC236}">
+                    <a16:creationId xmlns:a16="http://schemas.microsoft.com/office/drawing/2014/main" id="{DABCA7AF-6723-2C7D-9066-C596DBE2BDAC}"/>
+                  </a:ext>
+                </a:extLst>
+              </p14:cNvPr>
+              <p14:cNvContentPartPr/>
+              <p14:nvPr/>
+            </p14:nvContentPartPr>
+            <p14:xfrm>
+              <a:off x="10274773" y="1735487"/>
+              <a:ext cx="447480" cy="766080"/>
+            </p14:xfrm>
+          </p:contentPart>
+        </mc:Choice>
+        <mc:Fallback>
+          <p:pic>
+            <p:nvPicPr>
+              <p:cNvPr id="7" name="Ink 6">
+                <a:extLst>
+                  <a:ext uri="{FF2B5EF4-FFF2-40B4-BE49-F238E27FC236}">
+                    <a16:creationId xmlns:a16="http://schemas.microsoft.com/office/drawing/2014/main" id="{DABCA7AF-6723-2C7D-9066-C596DBE2BDAC}"/>
+                  </a:ext>
+                </a:extLst>
+              </p:cNvPr>
+              <p:cNvPicPr/>
+              <p:nvPr/>
+            </p:nvPicPr>
+            <p:blipFill>
+              <a:blip r:embed="rId5"/>
+              <a:stretch>
+                <a:fillRect/>
+              </a:stretch>
+            </p:blipFill>
+            <p:spPr>
+              <a:xfrm>
+                <a:off x="10211773" y="1672847"/>
+                <a:ext cx="573120" cy="891720"/>
+              </a:xfrm>
+              <a:prstGeom prst="rect">
+                <a:avLst/>
+              </a:prstGeom>
+            </p:spPr>
+          </p:pic>
+        </mc:Fallback>
+      </mc:AlternateContent>
+      <mc:AlternateContent xmlns:mc="http://schemas.openxmlformats.org/markup-compatibility/2006">
+        <mc:Choice xmlns:p14="http://schemas.microsoft.com/office/powerpoint/2010/main" Requires="p14">
+          <p:contentPart p14:bwMode="auto" r:id="rId6">
+            <p14:nvContentPartPr>
+              <p14:cNvPr id="8" name="Ink 7">
+                <a:extLst>
+                  <a:ext uri="{FF2B5EF4-FFF2-40B4-BE49-F238E27FC236}">
+                    <a16:creationId xmlns:a16="http://schemas.microsoft.com/office/drawing/2014/main" id="{8C83603A-FE42-D96B-E79F-8754A05C4C20}"/>
+                  </a:ext>
+                </a:extLst>
+              </p14:cNvPr>
+              <p14:cNvContentPartPr/>
+              <p14:nvPr/>
+            </p14:nvContentPartPr>
+            <p14:xfrm>
+              <a:off x="10381693" y="3975047"/>
+              <a:ext cx="210960" cy="388080"/>
+            </p14:xfrm>
+          </p:contentPart>
+        </mc:Choice>
+        <mc:Fallback>
+          <p:pic>
+            <p:nvPicPr>
+              <p:cNvPr id="8" name="Ink 7">
+                <a:extLst>
+                  <a:ext uri="{FF2B5EF4-FFF2-40B4-BE49-F238E27FC236}">
+                    <a16:creationId xmlns:a16="http://schemas.microsoft.com/office/drawing/2014/main" id="{8C83603A-FE42-D96B-E79F-8754A05C4C20}"/>
+                  </a:ext>
+                </a:extLst>
+              </p:cNvPr>
+              <p:cNvPicPr/>
+              <p:nvPr/>
+            </p:nvPicPr>
+            <p:blipFill>
+              <a:blip r:embed="rId7"/>
+              <a:stretch>
+                <a:fillRect/>
+              </a:stretch>
+            </p:blipFill>
+            <p:spPr>
+              <a:xfrm>
+                <a:off x="10318693" y="3912047"/>
+                <a:ext cx="336600" cy="513720"/>
+              </a:xfrm>
+              <a:prstGeom prst="rect">
+                <a:avLst/>
+              </a:prstGeom>
+            </p:spPr>
+          </p:pic>
+        </mc:Fallback>
+      </mc:AlternateContent>
+      <p:grpSp>
+        <p:nvGrpSpPr>
+          <p:cNvPr id="14" name="Group 13">
+            <a:extLst>
+              <a:ext uri="{FF2B5EF4-FFF2-40B4-BE49-F238E27FC236}">
+                <a16:creationId xmlns:a16="http://schemas.microsoft.com/office/drawing/2014/main" id="{F8F33CF3-BAFC-E7A6-C5C7-2EA9469B5223}"/>
+              </a:ext>
+            </a:extLst>
+          </p:cNvPr>
+          <p:cNvGrpSpPr/>
+          <p:nvPr/>
+        </p:nvGrpSpPr>
+        <p:grpSpPr>
+          <a:xfrm>
+            <a:off x="10955893" y="1794887"/>
+            <a:ext cx="995760" cy="330480"/>
+            <a:chOff x="10955893" y="1794887"/>
+            <a:chExt cx="995760" cy="330480"/>
+          </a:xfrm>
+        </p:grpSpPr>
+        <mc:AlternateContent xmlns:mc="http://schemas.openxmlformats.org/markup-compatibility/2006">
+          <mc:Choice xmlns:p14="http://schemas.microsoft.com/office/powerpoint/2010/main" Requires="p14">
+            <p:contentPart p14:bwMode="auto" r:id="rId8">
+              <p14:nvContentPartPr>
+                <p14:cNvPr id="9" name="Ink 8">
+                  <a:extLst>
+                    <a:ext uri="{FF2B5EF4-FFF2-40B4-BE49-F238E27FC236}">
+                      <a16:creationId xmlns:a16="http://schemas.microsoft.com/office/drawing/2014/main" id="{1BE72EBC-F190-D234-281D-AC1D1FB28F06}"/>
+                    </a:ext>
+                  </a:extLst>
+                </p14:cNvPr>
+                <p14:cNvContentPartPr/>
+                <p14:nvPr/>
+              </p14:nvContentPartPr>
+              <p14:xfrm>
+                <a:off x="10955893" y="1860047"/>
+                <a:ext cx="81360" cy="265320"/>
+              </p14:xfrm>
+            </p:contentPart>
+          </mc:Choice>
+          <mc:Fallback>
+            <p:pic>
+              <p:nvPicPr>
+                <p:cNvPr id="9" name="Ink 8">
+                  <a:extLst>
+                    <a:ext uri="{FF2B5EF4-FFF2-40B4-BE49-F238E27FC236}">
+                      <a16:creationId xmlns:a16="http://schemas.microsoft.com/office/drawing/2014/main" id="{1BE72EBC-F190-D234-281D-AC1D1FB28F06}"/>
+                    </a:ext>
+                  </a:extLst>
+                </p:cNvPr>
+                <p:cNvPicPr/>
+                <p:nvPr/>
+              </p:nvPicPr>
+              <p:blipFill>
+                <a:blip r:embed="rId9"/>
+                <a:stretch>
+                  <a:fillRect/>
+                </a:stretch>
+              </p:blipFill>
+              <p:spPr>
+                <a:xfrm>
+                  <a:off x="10937893" y="1842407"/>
+                  <a:ext cx="117000" cy="300960"/>
+                </a:xfrm>
+                <a:prstGeom prst="rect">
+                  <a:avLst/>
+                </a:prstGeom>
+              </p:spPr>
+            </p:pic>
+          </mc:Fallback>
+        </mc:AlternateContent>
+        <mc:AlternateContent xmlns:mc="http://schemas.openxmlformats.org/markup-compatibility/2006">
+          <mc:Choice xmlns:p14="http://schemas.microsoft.com/office/powerpoint/2010/main" Requires="p14">
+            <p:contentPart p14:bwMode="auto" r:id="rId10">
+              <p14:nvContentPartPr>
+                <p14:cNvPr id="10" name="Ink 9">
+                  <a:extLst>
+                    <a:ext uri="{FF2B5EF4-FFF2-40B4-BE49-F238E27FC236}">
+                      <a16:creationId xmlns:a16="http://schemas.microsoft.com/office/drawing/2014/main" id="{5287171E-06E2-8CD6-8E90-55B0960D0298}"/>
+                    </a:ext>
+                  </a:extLst>
+                </p14:cNvPr>
+                <p14:cNvContentPartPr/>
+                <p14:nvPr/>
+              </p14:nvContentPartPr>
+              <p14:xfrm>
+                <a:off x="11167573" y="1844567"/>
+                <a:ext cx="161640" cy="205920"/>
+              </p14:xfrm>
+            </p:contentPart>
+          </mc:Choice>
+          <mc:Fallback>
+            <p:pic>
+              <p:nvPicPr>
+                <p:cNvPr id="10" name="Ink 9">
+                  <a:extLst>
+                    <a:ext uri="{FF2B5EF4-FFF2-40B4-BE49-F238E27FC236}">
+                      <a16:creationId xmlns:a16="http://schemas.microsoft.com/office/drawing/2014/main" id="{5287171E-06E2-8CD6-8E90-55B0960D0298}"/>
+                    </a:ext>
+                  </a:extLst>
+                </p:cNvPr>
+                <p:cNvPicPr/>
+                <p:nvPr/>
+              </p:nvPicPr>
+              <p:blipFill>
+                <a:blip r:embed="rId11"/>
+                <a:stretch>
+                  <a:fillRect/>
+                </a:stretch>
+              </p:blipFill>
+              <p:spPr>
+                <a:xfrm>
+                  <a:off x="11149573" y="1826567"/>
+                  <a:ext cx="197280" cy="241560"/>
+                </a:xfrm>
+                <a:prstGeom prst="rect">
+                  <a:avLst/>
+                </a:prstGeom>
+              </p:spPr>
+            </p:pic>
+          </mc:Fallback>
+        </mc:AlternateContent>
+        <mc:AlternateContent xmlns:mc="http://schemas.openxmlformats.org/markup-compatibility/2006">
+          <mc:Choice xmlns:p14="http://schemas.microsoft.com/office/powerpoint/2010/main" Requires="p14">
+            <p:contentPart p14:bwMode="auto" r:id="rId12">
+              <p14:nvContentPartPr>
+                <p14:cNvPr id="11" name="Ink 10">
+                  <a:extLst>
+                    <a:ext uri="{FF2B5EF4-FFF2-40B4-BE49-F238E27FC236}">
+                      <a16:creationId xmlns:a16="http://schemas.microsoft.com/office/drawing/2014/main" id="{2054F2F8-89B7-F617-6D3B-6F29284D6F50}"/>
+                    </a:ext>
+                  </a:extLst>
+                </p14:cNvPr>
+                <p14:cNvContentPartPr/>
+                <p14:nvPr/>
+              </p14:nvContentPartPr>
+              <p14:xfrm>
+                <a:off x="11438293" y="1794887"/>
+                <a:ext cx="143280" cy="254160"/>
+              </p14:xfrm>
+            </p:contentPart>
+          </mc:Choice>
+          <mc:Fallback>
+            <p:pic>
+              <p:nvPicPr>
+                <p:cNvPr id="11" name="Ink 10">
+                  <a:extLst>
+                    <a:ext uri="{FF2B5EF4-FFF2-40B4-BE49-F238E27FC236}">
+                      <a16:creationId xmlns:a16="http://schemas.microsoft.com/office/drawing/2014/main" id="{2054F2F8-89B7-F617-6D3B-6F29284D6F50}"/>
+                    </a:ext>
+                  </a:extLst>
+                </p:cNvPr>
+                <p:cNvPicPr/>
+                <p:nvPr/>
+              </p:nvPicPr>
+              <p:blipFill>
+                <a:blip r:embed="rId13"/>
+                <a:stretch>
+                  <a:fillRect/>
+                </a:stretch>
+              </p:blipFill>
+              <p:spPr>
+                <a:xfrm>
+                  <a:off x="11420293" y="1776887"/>
+                  <a:ext cx="178920" cy="289800"/>
+                </a:xfrm>
+                <a:prstGeom prst="rect">
+                  <a:avLst/>
+                </a:prstGeom>
+              </p:spPr>
+            </p:pic>
+          </mc:Fallback>
+        </mc:AlternateContent>
+        <mc:AlternateContent xmlns:mc="http://schemas.openxmlformats.org/markup-compatibility/2006">
+          <mc:Choice xmlns:p14="http://schemas.microsoft.com/office/powerpoint/2010/main" Requires="p14">
+            <p:contentPart p14:bwMode="auto" r:id="rId14">
+              <p14:nvContentPartPr>
+                <p14:cNvPr id="12" name="Ink 11">
+                  <a:extLst>
+                    <a:ext uri="{FF2B5EF4-FFF2-40B4-BE49-F238E27FC236}">
+                      <a16:creationId xmlns:a16="http://schemas.microsoft.com/office/drawing/2014/main" id="{2151B651-9AD4-E33D-93A8-EB4D457A8509}"/>
+                    </a:ext>
+                  </a:extLst>
+                </p14:cNvPr>
+                <p14:cNvContentPartPr/>
+                <p14:nvPr/>
+              </p14:nvContentPartPr>
+              <p14:xfrm>
+                <a:off x="11709013" y="1845287"/>
+                <a:ext cx="242640" cy="167400"/>
+              </p14:xfrm>
+            </p:contentPart>
+          </mc:Choice>
+          <mc:Fallback>
+            <p:pic>
+              <p:nvPicPr>
+                <p:cNvPr id="12" name="Ink 11">
+                  <a:extLst>
+                    <a:ext uri="{FF2B5EF4-FFF2-40B4-BE49-F238E27FC236}">
+                      <a16:creationId xmlns:a16="http://schemas.microsoft.com/office/drawing/2014/main" id="{2151B651-9AD4-E33D-93A8-EB4D457A8509}"/>
+                    </a:ext>
+                  </a:extLst>
+                </p:cNvPr>
+                <p:cNvPicPr/>
+                <p:nvPr/>
+              </p:nvPicPr>
+              <p:blipFill>
+                <a:blip r:embed="rId15"/>
+                <a:stretch>
+                  <a:fillRect/>
+                </a:stretch>
+              </p:blipFill>
+              <p:spPr>
+                <a:xfrm>
+                  <a:off x="11691373" y="1827647"/>
+                  <a:ext cx="278280" cy="203040"/>
+                </a:xfrm>
+                <a:prstGeom prst="rect">
+                  <a:avLst/>
+                </a:prstGeom>
+              </p:spPr>
+            </p:pic>
+          </mc:Fallback>
+        </mc:AlternateContent>
+      </p:grpSp>
+      <p:grpSp>
+        <p:nvGrpSpPr>
+          <p:cNvPr id="20" name="Group 19">
+            <a:extLst>
+              <a:ext uri="{FF2B5EF4-FFF2-40B4-BE49-F238E27FC236}">
+                <a16:creationId xmlns:a16="http://schemas.microsoft.com/office/drawing/2014/main" id="{80389C47-2DF7-4E50-AC89-03E2218326CB}"/>
+              </a:ext>
+            </a:extLst>
+          </p:cNvPr>
+          <p:cNvGrpSpPr/>
+          <p:nvPr/>
+        </p:nvGrpSpPr>
+        <p:grpSpPr>
+          <a:xfrm>
+            <a:off x="11332093" y="3831047"/>
+            <a:ext cx="860760" cy="532080"/>
+            <a:chOff x="11332093" y="3831047"/>
+            <a:chExt cx="860760" cy="532080"/>
+          </a:xfrm>
+        </p:grpSpPr>
+        <mc:AlternateContent xmlns:mc="http://schemas.openxmlformats.org/markup-compatibility/2006">
+          <mc:Choice xmlns:p14="http://schemas.microsoft.com/office/powerpoint/2010/main" Requires="p14">
+            <p:contentPart p14:bwMode="auto" r:id="rId16">
+              <p14:nvContentPartPr>
+                <p14:cNvPr id="16" name="Ink 15">
+                  <a:extLst>
+                    <a:ext uri="{FF2B5EF4-FFF2-40B4-BE49-F238E27FC236}">
+                      <a16:creationId xmlns:a16="http://schemas.microsoft.com/office/drawing/2014/main" id="{A2CA2E82-2959-9DD2-9417-6F11BE5ABE62}"/>
+                    </a:ext>
+                  </a:extLst>
+                </p14:cNvPr>
+                <p14:cNvContentPartPr/>
+                <p14:nvPr/>
+              </p14:nvContentPartPr>
+              <p14:xfrm>
+                <a:off x="11332093" y="4016087"/>
+                <a:ext cx="95760" cy="243720"/>
+              </p14:xfrm>
+            </p:contentPart>
+          </mc:Choice>
+          <mc:Fallback>
+            <p:pic>
+              <p:nvPicPr>
+                <p:cNvPr id="16" name="Ink 15">
+                  <a:extLst>
+                    <a:ext uri="{FF2B5EF4-FFF2-40B4-BE49-F238E27FC236}">
+                      <a16:creationId xmlns:a16="http://schemas.microsoft.com/office/drawing/2014/main" id="{A2CA2E82-2959-9DD2-9417-6F11BE5ABE62}"/>
+                    </a:ext>
+                  </a:extLst>
+                </p:cNvPr>
+                <p:cNvPicPr/>
+                <p:nvPr/>
+              </p:nvPicPr>
+              <p:blipFill>
+                <a:blip r:embed="rId17"/>
+                <a:stretch>
+                  <a:fillRect/>
+                </a:stretch>
+              </p:blipFill>
+              <p:spPr>
+                <a:xfrm>
+                  <a:off x="11314453" y="3998087"/>
+                  <a:ext cx="131400" cy="279360"/>
+                </a:xfrm>
+                <a:prstGeom prst="rect">
+                  <a:avLst/>
+                </a:prstGeom>
+              </p:spPr>
+            </p:pic>
+          </mc:Fallback>
+        </mc:AlternateContent>
+        <mc:AlternateContent xmlns:mc="http://schemas.openxmlformats.org/markup-compatibility/2006">
+          <mc:Choice xmlns:p14="http://schemas.microsoft.com/office/powerpoint/2010/main" Requires="p14">
+            <p:contentPart p14:bwMode="auto" r:id="rId18">
+              <p14:nvContentPartPr>
+                <p14:cNvPr id="17" name="Ink 16">
+                  <a:extLst>
+                    <a:ext uri="{FF2B5EF4-FFF2-40B4-BE49-F238E27FC236}">
+                      <a16:creationId xmlns:a16="http://schemas.microsoft.com/office/drawing/2014/main" id="{1C4F3452-3EFC-C8BB-483A-54308F4A61CB}"/>
+                    </a:ext>
+                  </a:extLst>
+                </p14:cNvPr>
+                <p14:cNvContentPartPr/>
+                <p14:nvPr/>
+              </p14:nvContentPartPr>
+              <p14:xfrm>
+                <a:off x="11636653" y="3886127"/>
+                <a:ext cx="187920" cy="289800"/>
+              </p14:xfrm>
+            </p:contentPart>
+          </mc:Choice>
+          <mc:Fallback>
+            <p:pic>
+              <p:nvPicPr>
+                <p:cNvPr id="17" name="Ink 16">
+                  <a:extLst>
+                    <a:ext uri="{FF2B5EF4-FFF2-40B4-BE49-F238E27FC236}">
+                      <a16:creationId xmlns:a16="http://schemas.microsoft.com/office/drawing/2014/main" id="{1C4F3452-3EFC-C8BB-483A-54308F4A61CB}"/>
+                    </a:ext>
+                  </a:extLst>
+                </p:cNvPr>
+                <p:cNvPicPr/>
+                <p:nvPr/>
+              </p:nvPicPr>
+              <p:blipFill>
+                <a:blip r:embed="rId19"/>
+                <a:stretch>
+                  <a:fillRect/>
+                </a:stretch>
+              </p:blipFill>
+              <p:spPr>
+                <a:xfrm>
+                  <a:off x="11619013" y="3868487"/>
+                  <a:ext cx="223560" cy="325440"/>
+                </a:xfrm>
+                <a:prstGeom prst="rect">
+                  <a:avLst/>
+                </a:prstGeom>
+              </p:spPr>
+            </p:pic>
+          </mc:Fallback>
+        </mc:AlternateContent>
+        <mc:AlternateContent xmlns:mc="http://schemas.openxmlformats.org/markup-compatibility/2006">
+          <mc:Choice xmlns:p14="http://schemas.microsoft.com/office/powerpoint/2010/main" Requires="p14">
+            <p:contentPart p14:bwMode="auto" r:id="rId20">
+              <p14:nvContentPartPr>
+                <p14:cNvPr id="18" name="Ink 17">
+                  <a:extLst>
+                    <a:ext uri="{FF2B5EF4-FFF2-40B4-BE49-F238E27FC236}">
+                      <a16:creationId xmlns:a16="http://schemas.microsoft.com/office/drawing/2014/main" id="{52CF8459-8CB6-B095-3F2F-BECCA85C1504}"/>
+                    </a:ext>
+                  </a:extLst>
+                </p14:cNvPr>
+                <p14:cNvContentPartPr/>
+                <p14:nvPr/>
+              </p14:nvContentPartPr>
+              <p14:xfrm>
+                <a:off x="11980093" y="3831047"/>
+                <a:ext cx="85680" cy="307080"/>
+              </p14:xfrm>
+            </p:contentPart>
+          </mc:Choice>
+          <mc:Fallback>
+            <p:pic>
+              <p:nvPicPr>
+                <p:cNvPr id="18" name="Ink 17">
+                  <a:extLst>
+                    <a:ext uri="{FF2B5EF4-FFF2-40B4-BE49-F238E27FC236}">
+                      <a16:creationId xmlns:a16="http://schemas.microsoft.com/office/drawing/2014/main" id="{52CF8459-8CB6-B095-3F2F-BECCA85C1504}"/>
+                    </a:ext>
+                  </a:extLst>
+                </p:cNvPr>
+                <p:cNvPicPr/>
+                <p:nvPr/>
+              </p:nvPicPr>
+              <p:blipFill>
+                <a:blip r:embed="rId21"/>
+                <a:stretch>
+                  <a:fillRect/>
+                </a:stretch>
+              </p:blipFill>
+              <p:spPr>
+                <a:xfrm>
+                  <a:off x="11962453" y="3813407"/>
+                  <a:ext cx="121320" cy="342720"/>
+                </a:xfrm>
+                <a:prstGeom prst="rect">
+                  <a:avLst/>
+                </a:prstGeom>
+              </p:spPr>
+            </p:pic>
+          </mc:Fallback>
+        </mc:AlternateContent>
+        <mc:AlternateContent xmlns:mc="http://schemas.openxmlformats.org/markup-compatibility/2006">
+          <mc:Choice xmlns:p14="http://schemas.microsoft.com/office/powerpoint/2010/main" Requires="p14">
+            <p:contentPart p14:bwMode="auto" r:id="rId22">
+              <p14:nvContentPartPr>
+                <p14:cNvPr id="19" name="Ink 18">
+                  <a:extLst>
+                    <a:ext uri="{FF2B5EF4-FFF2-40B4-BE49-F238E27FC236}">
+                      <a16:creationId xmlns:a16="http://schemas.microsoft.com/office/drawing/2014/main" id="{4243751C-6893-88C1-33AC-148358F0C989}"/>
+                    </a:ext>
+                  </a:extLst>
+                </p14:cNvPr>
+                <p14:cNvContentPartPr/>
+                <p14:nvPr/>
+              </p14:nvContentPartPr>
+              <p14:xfrm>
+                <a:off x="12022573" y="4193567"/>
+                <a:ext cx="170280" cy="169560"/>
+              </p14:xfrm>
+            </p:contentPart>
+          </mc:Choice>
+          <mc:Fallback>
+            <p:pic>
+              <p:nvPicPr>
+                <p:cNvPr id="19" name="Ink 18">
+                  <a:extLst>
+                    <a:ext uri="{FF2B5EF4-FFF2-40B4-BE49-F238E27FC236}">
+                      <a16:creationId xmlns:a16="http://schemas.microsoft.com/office/drawing/2014/main" id="{4243751C-6893-88C1-33AC-148358F0C989}"/>
+                    </a:ext>
+                  </a:extLst>
+                </p:cNvPr>
+                <p:cNvPicPr/>
+                <p:nvPr/>
+              </p:nvPicPr>
+              <p:blipFill>
+                <a:blip r:embed="rId23"/>
+                <a:stretch>
+                  <a:fillRect/>
+                </a:stretch>
+              </p:blipFill>
+              <p:spPr>
+                <a:xfrm>
+                  <a:off x="12004573" y="4175567"/>
+                  <a:ext cx="205920" cy="205200"/>
+                </a:xfrm>
+                <a:prstGeom prst="rect">
+                  <a:avLst/>
+                </a:prstGeom>
+              </p:spPr>
+            </p:pic>
+          </mc:Fallback>
+        </mc:AlternateContent>
+      </p:grpSp>
+      <mc:AlternateContent xmlns:mc="http://schemas.openxmlformats.org/markup-compatibility/2006">
+        <mc:Choice xmlns:p14="http://schemas.microsoft.com/office/powerpoint/2010/main" Requires="p14">
+          <p:contentPart p14:bwMode="auto" r:id="rId24">
+            <p14:nvContentPartPr>
+              <p14:cNvPr id="21" name="Ink 20">
+                <a:extLst>
+                  <a:ext uri="{FF2B5EF4-FFF2-40B4-BE49-F238E27FC236}">
+                    <a16:creationId xmlns:a16="http://schemas.microsoft.com/office/drawing/2014/main" id="{927E7234-FB57-C1B2-7CC1-00C133A1E295}"/>
+                  </a:ext>
+                </a:extLst>
+              </p14:cNvPr>
+              <p14:cNvContentPartPr/>
+              <p14:nvPr/>
+            </p14:nvContentPartPr>
+            <p14:xfrm>
+              <a:off x="-1041467" y="2971367"/>
+              <a:ext cx="1080" cy="360"/>
+            </p14:xfrm>
+          </p:contentPart>
+        </mc:Choice>
+        <mc:Fallback>
+          <p:pic>
+            <p:nvPicPr>
+              <p:cNvPr id="21" name="Ink 20">
+                <a:extLst>
+                  <a:ext uri="{FF2B5EF4-FFF2-40B4-BE49-F238E27FC236}">
+                    <a16:creationId xmlns:a16="http://schemas.microsoft.com/office/drawing/2014/main" id="{927E7234-FB57-C1B2-7CC1-00C133A1E295}"/>
+                  </a:ext>
+                </a:extLst>
+              </p:cNvPr>
+              <p:cNvPicPr/>
+              <p:nvPr/>
+            </p:nvPicPr>
+            <p:blipFill>
+              <a:blip r:embed="rId25"/>
+              <a:stretch>
+                <a:fillRect/>
+              </a:stretch>
+            </p:blipFill>
+            <p:spPr>
+              <a:xfrm>
+                <a:off x="-1059467" y="2953727"/>
+                <a:ext cx="36720" cy="36000"/>
+              </a:xfrm>
+              <a:prstGeom prst="rect">
+                <a:avLst/>
+              </a:prstGeom>
+            </p:spPr>
+          </p:pic>
+        </mc:Fallback>
+      </mc:AlternateContent>
     </p:spTree>
     <p:extLst>
       <p:ext uri="{BB962C8B-B14F-4D97-AF65-F5344CB8AC3E}">
@@ -5294,15 +5795,15 @@
           </p:nvPr>
         </p:nvPicPr>
         <p:blipFill>
-          <a:blip r:embed="rId2"/>
+          <a:blip r:embed="rId3"/>
           <a:stretch>
             <a:fillRect/>
           </a:stretch>
         </p:blipFill>
         <p:spPr>
           <a:xfrm>
-            <a:off x="936674" y="1571113"/>
-            <a:ext cx="4725572" cy="4307421"/>
+            <a:off x="936673" y="1571113"/>
+            <a:ext cx="4913793" cy="4478987"/>
           </a:xfrm>
           <a:prstGeom prst="rect">
             <a:avLst/>
@@ -5339,7 +5840,7 @@
           <a:p>
             <a:r>
               <a:rPr lang="en-US" dirty="0">
-                <a:hlinkClick r:id="rId3"/>
+                <a:hlinkClick r:id="rId4"/>
               </a:rPr>
               <a:t>Analyze output Sine wave from prototype · MAMS</a:t>
             </a:r>
@@ -5362,15 +5863,15 @@
           <p:nvPr/>
         </p:nvPicPr>
         <p:blipFill>
-          <a:blip r:embed="rId4"/>
+          <a:blip r:embed="rId5"/>
           <a:stretch>
             <a:fillRect/>
           </a:stretch>
         </p:blipFill>
         <p:spPr>
           <a:xfrm>
-            <a:off x="6096000" y="1571113"/>
-            <a:ext cx="5445342" cy="4307421"/>
+            <a:off x="5879110" y="1571113"/>
+            <a:ext cx="5662232" cy="4478987"/>
           </a:xfrm>
           <a:prstGeom prst="rect">
             <a:avLst/>

</xml_diff>